<commit_message>
Day 5 done: docs, decks, runbook
</commit_message>
<xml_diff>
--- a/docs/AarogyaTwinX_Architecture.pptx
+++ b/docs/AarogyaTwinX_Architecture.pptx
@@ -171,7 +171,7 @@
         </p:nvSpPr>
         <p:spPr>
           <a:xfrm>
-            <a:off x="749808" y="1261872"/>
+            <a:off x="658368" y="1261872"/>
             <a:ext cx="10698480" cy="4800600"/>
           </a:xfrm>
           <a:prstGeom prst="rect">
@@ -387,8 +387,8 @@
         </p:nvSpPr>
         <p:spPr>
           <a:xfrm>
-            <a:off x="749808" y="1261872"/>
-            <a:ext cx="10698480" cy="4800600"/>
+            <a:off x="658368" y="1261872"/>
+            <a:ext cx="3886200" cy="4800600"/>
           </a:xfrm>
           <a:prstGeom prst="rect">
             <a:avLst/>
@@ -406,7 +406,7 @@
               <a:buChar char="•"/>
             </a:pPr>
             <a:r>
-              <a:rPr lang="en-US" sz="1700">
+              <a:rPr lang="en-US" sz="1500">
                 <a:solidFill>
                   <a:srgbClr val="26364D"/>
                 </a:solidFill>
@@ -414,14 +414,14 @@
               </a:rPr>
               <a:t>Seed 2026 -&gt; synthetic simulator -&gt; patient-disjoint split</a:t>
             </a:r>
-            <a:endParaRPr lang="en-US" sz="1700"/>
+            <a:endParaRPr lang="en-US" sz="1500"/>
           </a:p>
           <a:p>
             <a:pPr lvl="0">
               <a:buChar char="•"/>
             </a:pPr>
             <a:r>
-              <a:rPr lang="en-US" sz="1700">
+              <a:rPr lang="en-US" sz="1500">
                 <a:solidFill>
                   <a:srgbClr val="26364D"/>
                 </a:solidFill>
@@ -429,14 +429,14 @@
               </a:rPr>
               <a:t>Past-only feature builder -&gt; CPU temporal model</a:t>
             </a:r>
-            <a:endParaRPr lang="en-US" sz="1700"/>
+            <a:endParaRPr lang="en-US" sz="1500"/>
           </a:p>
           <a:p>
             <a:pPr lvl="0">
               <a:buChar char="•"/>
             </a:pPr>
             <a:r>
-              <a:rPr lang="en-US" sz="1700">
+              <a:rPr lang="en-US" sz="1500">
                 <a:solidFill>
                   <a:srgbClr val="26364D"/>
                 </a:solidFill>
@@ -444,14 +444,14 @@
               </a:rPr>
               <a:t>Calibration and bounded residual -&gt; joblib/JSON artifacts</a:t>
             </a:r>
-            <a:endParaRPr lang="en-US" sz="1700"/>
+            <a:endParaRPr lang="en-US" sz="1500"/>
           </a:p>
           <a:p>
             <a:pPr lvl="0">
               <a:buChar char="•"/>
             </a:pPr>
             <a:r>
-              <a:rPr lang="en-US" sz="1700">
+              <a:rPr lang="en-US" sz="1500">
                 <a:solidFill>
                   <a:srgbClr val="26364D"/>
                 </a:solidFill>
@@ -459,7 +459,849 @@
               </a:rPr>
               <a:t>FastAPI local API -&gt; React/Vite dashboard</a:t>
             </a:r>
-            <a:endParaRPr lang="en-US" sz="1700"/>
+            <a:endParaRPr lang="en-US" sz="1500"/>
+          </a:p>
+        </p:txBody>
+      </p:sp>
+      <p:sp>
+        <p:nvSpPr>
+          <p:cNvPr id="20" name="card-20"/>
+          <p:cNvSpPr/>
+          <p:nvPr/>
+        </p:nvSpPr>
+        <p:spPr>
+          <a:xfrm>
+            <a:off x="4892040" y="1417320"/>
+            <a:ext cx="1417320" cy="1024128"/>
+          </a:xfrm>
+          <a:prstGeom prst="rect">
+            <a:avLst/>
+          </a:prstGeom>
+          <a:solidFill>
+            <a:srgbClr val="159B9A"/>
+          </a:solidFill>
+          <a:ln>
+            <a:noFill/>
+          </a:ln>
+        </p:spPr>
+      </p:sp>
+      <p:sp>
+        <p:nvSpPr>
+          <p:cNvPr id="21" name="card-text-20"/>
+          <p:cNvSpPr/>
+          <p:nvPr/>
+        </p:nvSpPr>
+        <p:spPr>
+          <a:xfrm>
+            <a:off x="4983480" y="1508760"/>
+            <a:ext cx="1234440" cy="841248"/>
+          </a:xfrm>
+          <a:prstGeom prst="rect">
+            <a:avLst/>
+          </a:prstGeom>
+          <a:noFill/>
+          <a:ln>
+            <a:noFill/>
+          </a:ln>
+        </p:spPr>
+        <p:txBody>
+          <a:bodyPr wrap="square" rtlCol="0"/>
+          <a:lstStyle/>
+          <a:p>
+            <a:pPr lvl="0">
+              <a:buNone/>
+            </a:pPr>
+            <a:r>
+              <a:rPr lang="en-US" sz="1400" b="1">
+                <a:solidFill>
+                  <a:srgbClr val="FFFFFF"/>
+                </a:solidFill>
+                <a:latin typeface="Aptos"/>
+              </a:rPr>
+              <a:t>SIMULATE</a:t>
+            </a:r>
+            <a:endParaRPr lang="en-US" sz="1400"/>
+          </a:p>
+          <a:p>
+            <a:pPr lvl="0">
+              <a:buNone/>
+            </a:pPr>
+            <a:r>
+              <a:rPr lang="en-US" sz="900">
+                <a:solidFill>
+                  <a:srgbClr val="EAF4F5"/>
+                </a:solidFill>
+                <a:latin typeface="Aptos"/>
+              </a:rPr>
+              <a:t>seed 2026</a:t>
+            </a:r>
+            <a:endParaRPr lang="en-US" sz="900"/>
+          </a:p>
+        </p:txBody>
+      </p:sp>
+      <p:sp>
+        <p:nvSpPr>
+          <p:cNvPr id="22" name="arrow-22"/>
+          <p:cNvSpPr/>
+          <p:nvPr/>
+        </p:nvSpPr>
+        <p:spPr>
+          <a:xfrm>
+            <a:off x="6318504" y="1700784"/>
+            <a:ext cx="260000" cy="430000"/>
+          </a:xfrm>
+          <a:prstGeom prst="rect">
+            <a:avLst/>
+          </a:prstGeom>
+          <a:noFill/>
+          <a:ln>
+            <a:noFill/>
+          </a:ln>
+        </p:spPr>
+        <p:txBody>
+          <a:bodyPr wrap="square" rtlCol="0"/>
+          <a:lstStyle/>
+          <a:p>
+            <a:pPr lvl="0">
+              <a:buNone/>
+            </a:pPr>
+            <a:r>
+              <a:rPr lang="en-US" sz="2200" b="1">
+                <a:solidFill>
+                  <a:srgbClr val="7667E8"/>
+                </a:solidFill>
+                <a:latin typeface="Aptos"/>
+              </a:rPr>
+              <a:t>→</a:t>
+            </a:r>
+            <a:endParaRPr lang="en-US" sz="2200"/>
+          </a:p>
+        </p:txBody>
+      </p:sp>
+      <p:sp>
+        <p:nvSpPr>
+          <p:cNvPr id="23" name="card-23"/>
+          <p:cNvSpPr/>
+          <p:nvPr/>
+        </p:nvSpPr>
+        <p:spPr>
+          <a:xfrm>
+            <a:off x="6510528" y="1417320"/>
+            <a:ext cx="1417320" cy="1024128"/>
+          </a:xfrm>
+          <a:prstGeom prst="rect">
+            <a:avLst/>
+          </a:prstGeom>
+          <a:solidFill>
+            <a:srgbClr val="7667E8"/>
+          </a:solidFill>
+          <a:ln>
+            <a:noFill/>
+          </a:ln>
+        </p:spPr>
+      </p:sp>
+      <p:sp>
+        <p:nvSpPr>
+          <p:cNvPr id="24" name="card-text-23"/>
+          <p:cNvSpPr/>
+          <p:nvPr/>
+        </p:nvSpPr>
+        <p:spPr>
+          <a:xfrm>
+            <a:off x="6601968" y="1508760"/>
+            <a:ext cx="1234440" cy="841248"/>
+          </a:xfrm>
+          <a:prstGeom prst="rect">
+            <a:avLst/>
+          </a:prstGeom>
+          <a:noFill/>
+          <a:ln>
+            <a:noFill/>
+          </a:ln>
+        </p:spPr>
+        <p:txBody>
+          <a:bodyPr wrap="square" rtlCol="0"/>
+          <a:lstStyle/>
+          <a:p>
+            <a:pPr lvl="0">
+              <a:buNone/>
+            </a:pPr>
+            <a:r>
+              <a:rPr lang="en-US" sz="1400" b="1">
+                <a:solidFill>
+                  <a:srgbClr val="FFFFFF"/>
+                </a:solidFill>
+                <a:latin typeface="Aptos"/>
+              </a:rPr>
+              <a:t>SPLIT</a:t>
+            </a:r>
+            <a:endParaRPr lang="en-US" sz="1400"/>
+          </a:p>
+          <a:p>
+            <a:pPr lvl="0">
+              <a:buNone/>
+            </a:pPr>
+            <a:r>
+              <a:rPr lang="en-US" sz="900">
+                <a:solidFill>
+                  <a:srgbClr val="EAF4F5"/>
+                </a:solidFill>
+                <a:latin typeface="Aptos"/>
+              </a:rPr>
+              <a:t>patients</a:t>
+            </a:r>
+            <a:endParaRPr lang="en-US" sz="900"/>
+          </a:p>
+        </p:txBody>
+      </p:sp>
+      <p:sp>
+        <p:nvSpPr>
+          <p:cNvPr id="25" name="arrow-25"/>
+          <p:cNvSpPr/>
+          <p:nvPr/>
+        </p:nvSpPr>
+        <p:spPr>
+          <a:xfrm>
+            <a:off x="7936992" y="1700784"/>
+            <a:ext cx="260000" cy="430000"/>
+          </a:xfrm>
+          <a:prstGeom prst="rect">
+            <a:avLst/>
+          </a:prstGeom>
+          <a:noFill/>
+          <a:ln>
+            <a:noFill/>
+          </a:ln>
+        </p:spPr>
+        <p:txBody>
+          <a:bodyPr wrap="square" rtlCol="0"/>
+          <a:lstStyle/>
+          <a:p>
+            <a:pPr lvl="0">
+              <a:buNone/>
+            </a:pPr>
+            <a:r>
+              <a:rPr lang="en-US" sz="2200" b="1">
+                <a:solidFill>
+                  <a:srgbClr val="7667E8"/>
+                </a:solidFill>
+                <a:latin typeface="Aptos"/>
+              </a:rPr>
+              <a:t>→</a:t>
+            </a:r>
+            <a:endParaRPr lang="en-US" sz="2200"/>
+          </a:p>
+        </p:txBody>
+      </p:sp>
+      <p:sp>
+        <p:nvSpPr>
+          <p:cNvPr id="26" name="card-26"/>
+          <p:cNvSpPr/>
+          <p:nvPr/>
+        </p:nvSpPr>
+        <p:spPr>
+          <a:xfrm>
+            <a:off x="8129016" y="1417320"/>
+            <a:ext cx="1417320" cy="1024128"/>
+          </a:xfrm>
+          <a:prstGeom prst="rect">
+            <a:avLst/>
+          </a:prstGeom>
+          <a:solidFill>
+            <a:srgbClr val="159B9A"/>
+          </a:solidFill>
+          <a:ln>
+            <a:noFill/>
+          </a:ln>
+        </p:spPr>
+      </p:sp>
+      <p:sp>
+        <p:nvSpPr>
+          <p:cNvPr id="27" name="card-text-26"/>
+          <p:cNvSpPr/>
+          <p:nvPr/>
+        </p:nvSpPr>
+        <p:spPr>
+          <a:xfrm>
+            <a:off x="8220456" y="1508760"/>
+            <a:ext cx="1234440" cy="841248"/>
+          </a:xfrm>
+          <a:prstGeom prst="rect">
+            <a:avLst/>
+          </a:prstGeom>
+          <a:noFill/>
+          <a:ln>
+            <a:noFill/>
+          </a:ln>
+        </p:spPr>
+        <p:txBody>
+          <a:bodyPr wrap="square" rtlCol="0"/>
+          <a:lstStyle/>
+          <a:p>
+            <a:pPr lvl="0">
+              <a:buNone/>
+            </a:pPr>
+            <a:r>
+              <a:rPr lang="en-US" sz="1400" b="1">
+                <a:solidFill>
+                  <a:srgbClr val="FFFFFF"/>
+                </a:solidFill>
+                <a:latin typeface="Aptos"/>
+              </a:rPr>
+              <a:t>FEATURE</a:t>
+            </a:r>
+            <a:endParaRPr lang="en-US" sz="1400"/>
+          </a:p>
+          <a:p>
+            <a:pPr lvl="0">
+              <a:buNone/>
+            </a:pPr>
+            <a:r>
+              <a:rPr lang="en-US" sz="900">
+                <a:solidFill>
+                  <a:srgbClr val="EAF4F5"/>
+                </a:solidFill>
+                <a:latin typeface="Aptos"/>
+              </a:rPr>
+              <a:t>past-only</a:t>
+            </a:r>
+            <a:endParaRPr lang="en-US" sz="900"/>
+          </a:p>
+        </p:txBody>
+      </p:sp>
+      <p:sp>
+        <p:nvSpPr>
+          <p:cNvPr id="28" name="arrow-28"/>
+          <p:cNvSpPr/>
+          <p:nvPr/>
+        </p:nvSpPr>
+        <p:spPr>
+          <a:xfrm>
+            <a:off x="9555480" y="1700784"/>
+            <a:ext cx="260000" cy="430000"/>
+          </a:xfrm>
+          <a:prstGeom prst="rect">
+            <a:avLst/>
+          </a:prstGeom>
+          <a:noFill/>
+          <a:ln>
+            <a:noFill/>
+          </a:ln>
+        </p:spPr>
+        <p:txBody>
+          <a:bodyPr wrap="square" rtlCol="0"/>
+          <a:lstStyle/>
+          <a:p>
+            <a:pPr lvl="0">
+              <a:buNone/>
+            </a:pPr>
+            <a:r>
+              <a:rPr lang="en-US" sz="2200" b="1">
+                <a:solidFill>
+                  <a:srgbClr val="7667E8"/>
+                </a:solidFill>
+                <a:latin typeface="Aptos"/>
+              </a:rPr>
+              <a:t>→</a:t>
+            </a:r>
+            <a:endParaRPr lang="en-US" sz="2200"/>
+          </a:p>
+        </p:txBody>
+      </p:sp>
+      <p:sp>
+        <p:nvSpPr>
+          <p:cNvPr id="29" name="card-29"/>
+          <p:cNvSpPr/>
+          <p:nvPr/>
+        </p:nvSpPr>
+        <p:spPr>
+          <a:xfrm>
+            <a:off x="9747504" y="1417320"/>
+            <a:ext cx="1417320" cy="1024128"/>
+          </a:xfrm>
+          <a:prstGeom prst="rect">
+            <a:avLst/>
+          </a:prstGeom>
+          <a:solidFill>
+            <a:srgbClr val="7667E8"/>
+          </a:solidFill>
+          <a:ln>
+            <a:noFill/>
+          </a:ln>
+        </p:spPr>
+      </p:sp>
+      <p:sp>
+        <p:nvSpPr>
+          <p:cNvPr id="30" name="card-text-29"/>
+          <p:cNvSpPr/>
+          <p:nvPr/>
+        </p:nvSpPr>
+        <p:spPr>
+          <a:xfrm>
+            <a:off x="9838944" y="1508760"/>
+            <a:ext cx="1234440" cy="841248"/>
+          </a:xfrm>
+          <a:prstGeom prst="rect">
+            <a:avLst/>
+          </a:prstGeom>
+          <a:noFill/>
+          <a:ln>
+            <a:noFill/>
+          </a:ln>
+        </p:spPr>
+        <p:txBody>
+          <a:bodyPr wrap="square" rtlCol="0"/>
+          <a:lstStyle/>
+          <a:p>
+            <a:pPr lvl="0">
+              <a:buNone/>
+            </a:pPr>
+            <a:r>
+              <a:rPr lang="en-US" sz="1400" b="1">
+                <a:solidFill>
+                  <a:srgbClr val="FFFFFF"/>
+                </a:solidFill>
+                <a:latin typeface="Aptos"/>
+              </a:rPr>
+              <a:t>MODEL</a:t>
+            </a:r>
+            <a:endParaRPr lang="en-US" sz="1400"/>
+          </a:p>
+          <a:p>
+            <a:pPr lvl="0">
+              <a:buNone/>
+            </a:pPr>
+            <a:r>
+              <a:rPr lang="en-US" sz="900">
+                <a:solidFill>
+                  <a:srgbClr val="EAF4F5"/>
+                </a:solidFill>
+                <a:latin typeface="Aptos"/>
+              </a:rPr>
+              <a:t>CPU heads</a:t>
+            </a:r>
+            <a:endParaRPr lang="en-US" sz="900"/>
+          </a:p>
+        </p:txBody>
+      </p:sp>
+      <p:sp>
+        <p:nvSpPr>
+          <p:cNvPr id="31" name="card-31"/>
+          <p:cNvSpPr/>
+          <p:nvPr/>
+        </p:nvSpPr>
+        <p:spPr>
+          <a:xfrm>
+            <a:off x="4892040" y="3017520"/>
+            <a:ext cx="1417320" cy="1024128"/>
+          </a:xfrm>
+          <a:prstGeom prst="rect">
+            <a:avLst/>
+          </a:prstGeom>
+          <a:solidFill>
+            <a:srgbClr val="7667E8"/>
+          </a:solidFill>
+          <a:ln>
+            <a:noFill/>
+          </a:ln>
+        </p:spPr>
+      </p:sp>
+      <p:sp>
+        <p:nvSpPr>
+          <p:cNvPr id="32" name="card-text-31"/>
+          <p:cNvSpPr/>
+          <p:nvPr/>
+        </p:nvSpPr>
+        <p:spPr>
+          <a:xfrm>
+            <a:off x="4983480" y="3108960"/>
+            <a:ext cx="1234440" cy="841248"/>
+          </a:xfrm>
+          <a:prstGeom prst="rect">
+            <a:avLst/>
+          </a:prstGeom>
+          <a:noFill/>
+          <a:ln>
+            <a:noFill/>
+          </a:ln>
+        </p:spPr>
+        <p:txBody>
+          <a:bodyPr wrap="square" rtlCol="0"/>
+          <a:lstStyle/>
+          <a:p>
+            <a:pPr lvl="0">
+              <a:buNone/>
+            </a:pPr>
+            <a:r>
+              <a:rPr lang="en-US" sz="1400" b="1">
+                <a:solidFill>
+                  <a:srgbClr val="FFFFFF"/>
+                </a:solidFill>
+                <a:latin typeface="Aptos"/>
+              </a:rPr>
+              <a:t>CALIBRATE</a:t>
+            </a:r>
+            <a:endParaRPr lang="en-US" sz="1400"/>
+          </a:p>
+          <a:p>
+            <a:pPr lvl="0">
+              <a:buNone/>
+            </a:pPr>
+            <a:r>
+              <a:rPr lang="en-US" sz="900">
+                <a:solidFill>
+                  <a:srgbClr val="EAF4F5"/>
+                </a:solidFill>
+                <a:latin typeface="Aptos"/>
+              </a:rPr>
+              <a:t>probability + intervals</a:t>
+            </a:r>
+            <a:endParaRPr lang="en-US" sz="900"/>
+          </a:p>
+        </p:txBody>
+      </p:sp>
+      <p:sp>
+        <p:nvSpPr>
+          <p:cNvPr id="33" name="arrow-33"/>
+          <p:cNvSpPr/>
+          <p:nvPr/>
+        </p:nvSpPr>
+        <p:spPr>
+          <a:xfrm>
+            <a:off x="6318504" y="3300984"/>
+            <a:ext cx="260000" cy="430000"/>
+          </a:xfrm>
+          <a:prstGeom prst="rect">
+            <a:avLst/>
+          </a:prstGeom>
+          <a:noFill/>
+          <a:ln>
+            <a:noFill/>
+          </a:ln>
+        </p:spPr>
+        <p:txBody>
+          <a:bodyPr wrap="square" rtlCol="0"/>
+          <a:lstStyle/>
+          <a:p>
+            <a:pPr lvl="0">
+              <a:buNone/>
+            </a:pPr>
+            <a:r>
+              <a:rPr lang="en-US" sz="2200" b="1">
+                <a:solidFill>
+                  <a:srgbClr val="7667E8"/>
+                </a:solidFill>
+                <a:latin typeface="Aptos"/>
+              </a:rPr>
+              <a:t>→</a:t>
+            </a:r>
+            <a:endParaRPr lang="en-US" sz="2200"/>
+          </a:p>
+        </p:txBody>
+      </p:sp>
+      <p:sp>
+        <p:nvSpPr>
+          <p:cNvPr id="34" name="card-34"/>
+          <p:cNvSpPr/>
+          <p:nvPr/>
+        </p:nvSpPr>
+        <p:spPr>
+          <a:xfrm>
+            <a:off x="6510528" y="3017520"/>
+            <a:ext cx="1417320" cy="1024128"/>
+          </a:xfrm>
+          <a:prstGeom prst="rect">
+            <a:avLst/>
+          </a:prstGeom>
+          <a:solidFill>
+            <a:srgbClr val="159B9A"/>
+          </a:solidFill>
+          <a:ln>
+            <a:noFill/>
+          </a:ln>
+        </p:spPr>
+      </p:sp>
+      <p:sp>
+        <p:nvSpPr>
+          <p:cNvPr id="35" name="card-text-34"/>
+          <p:cNvSpPr/>
+          <p:nvPr/>
+        </p:nvSpPr>
+        <p:spPr>
+          <a:xfrm>
+            <a:off x="6601968" y="3108960"/>
+            <a:ext cx="1234440" cy="841248"/>
+          </a:xfrm>
+          <a:prstGeom prst="rect">
+            <a:avLst/>
+          </a:prstGeom>
+          <a:noFill/>
+          <a:ln>
+            <a:noFill/>
+          </a:ln>
+        </p:spPr>
+        <p:txBody>
+          <a:bodyPr wrap="square" rtlCol="0"/>
+          <a:lstStyle/>
+          <a:p>
+            <a:pPr lvl="0">
+              <a:buNone/>
+            </a:pPr>
+            <a:r>
+              <a:rPr lang="en-US" sz="1400" b="1">
+                <a:solidFill>
+                  <a:srgbClr val="FFFFFF"/>
+                </a:solidFill>
+                <a:latin typeface="Aptos"/>
+              </a:rPr>
+              <a:t>ENGINE</a:t>
+            </a:r>
+            <a:endParaRPr lang="en-US" sz="1400"/>
+          </a:p>
+          <a:p>
+            <a:pPr lvl="0">
+              <a:buNone/>
+            </a:pPr>
+            <a:r>
+              <a:rPr lang="en-US" sz="900">
+                <a:solidFill>
+                  <a:srgbClr val="EAF4F5"/>
+                </a:solidFill>
+                <a:latin typeface="Aptos"/>
+              </a:rPr>
+              <a:t>artifact load</a:t>
+            </a:r>
+            <a:endParaRPr lang="en-US" sz="900"/>
+          </a:p>
+        </p:txBody>
+      </p:sp>
+      <p:sp>
+        <p:nvSpPr>
+          <p:cNvPr id="36" name="arrow-36"/>
+          <p:cNvSpPr/>
+          <p:nvPr/>
+        </p:nvSpPr>
+        <p:spPr>
+          <a:xfrm>
+            <a:off x="7936992" y="3300984"/>
+            <a:ext cx="260000" cy="430000"/>
+          </a:xfrm>
+          <a:prstGeom prst="rect">
+            <a:avLst/>
+          </a:prstGeom>
+          <a:noFill/>
+          <a:ln>
+            <a:noFill/>
+          </a:ln>
+        </p:spPr>
+        <p:txBody>
+          <a:bodyPr wrap="square" rtlCol="0"/>
+          <a:lstStyle/>
+          <a:p>
+            <a:pPr lvl="0">
+              <a:buNone/>
+            </a:pPr>
+            <a:r>
+              <a:rPr lang="en-US" sz="2200" b="1">
+                <a:solidFill>
+                  <a:srgbClr val="7667E8"/>
+                </a:solidFill>
+                <a:latin typeface="Aptos"/>
+              </a:rPr>
+              <a:t>→</a:t>
+            </a:r>
+            <a:endParaRPr lang="en-US" sz="2200"/>
+          </a:p>
+        </p:txBody>
+      </p:sp>
+      <p:sp>
+        <p:nvSpPr>
+          <p:cNvPr id="37" name="card-37"/>
+          <p:cNvSpPr/>
+          <p:nvPr/>
+        </p:nvSpPr>
+        <p:spPr>
+          <a:xfrm>
+            <a:off x="8129016" y="3017520"/>
+            <a:ext cx="1417320" cy="1024128"/>
+          </a:xfrm>
+          <a:prstGeom prst="rect">
+            <a:avLst/>
+          </a:prstGeom>
+          <a:solidFill>
+            <a:srgbClr val="7667E8"/>
+          </a:solidFill>
+          <a:ln>
+            <a:noFill/>
+          </a:ln>
+        </p:spPr>
+      </p:sp>
+      <p:sp>
+        <p:nvSpPr>
+          <p:cNvPr id="38" name="card-text-37"/>
+          <p:cNvSpPr/>
+          <p:nvPr/>
+        </p:nvSpPr>
+        <p:spPr>
+          <a:xfrm>
+            <a:off x="8220456" y="3108960"/>
+            <a:ext cx="1234440" cy="841248"/>
+          </a:xfrm>
+          <a:prstGeom prst="rect">
+            <a:avLst/>
+          </a:prstGeom>
+          <a:noFill/>
+          <a:ln>
+            <a:noFill/>
+          </a:ln>
+        </p:spPr>
+        <p:txBody>
+          <a:bodyPr wrap="square" rtlCol="0"/>
+          <a:lstStyle/>
+          <a:p>
+            <a:pPr lvl="0">
+              <a:buNone/>
+            </a:pPr>
+            <a:r>
+              <a:rPr lang="en-US" sz="1400" b="1">
+                <a:solidFill>
+                  <a:srgbClr val="FFFFFF"/>
+                </a:solidFill>
+                <a:latin typeface="Aptos"/>
+              </a:rPr>
+              <a:t>API</a:t>
+            </a:r>
+            <a:endParaRPr lang="en-US" sz="1400"/>
+          </a:p>
+          <a:p>
+            <a:pPr lvl="0">
+              <a:buNone/>
+            </a:pPr>
+            <a:r>
+              <a:rPr lang="en-US" sz="900">
+                <a:solidFill>
+                  <a:srgbClr val="EAF4F5"/>
+                </a:solidFill>
+                <a:latin typeface="Aptos"/>
+              </a:rPr>
+              <a:t>localhost</a:t>
+            </a:r>
+            <a:endParaRPr lang="en-US" sz="900"/>
+          </a:p>
+        </p:txBody>
+      </p:sp>
+      <p:sp>
+        <p:nvSpPr>
+          <p:cNvPr id="39" name="arrow-39"/>
+          <p:cNvSpPr/>
+          <p:nvPr/>
+        </p:nvSpPr>
+        <p:spPr>
+          <a:xfrm>
+            <a:off x="9555480" y="3300984"/>
+            <a:ext cx="260000" cy="430000"/>
+          </a:xfrm>
+          <a:prstGeom prst="rect">
+            <a:avLst/>
+          </a:prstGeom>
+          <a:noFill/>
+          <a:ln>
+            <a:noFill/>
+          </a:ln>
+        </p:spPr>
+        <p:txBody>
+          <a:bodyPr wrap="square" rtlCol="0"/>
+          <a:lstStyle/>
+          <a:p>
+            <a:pPr lvl="0">
+              <a:buNone/>
+            </a:pPr>
+            <a:r>
+              <a:rPr lang="en-US" sz="2200" b="1">
+                <a:solidFill>
+                  <a:srgbClr val="7667E8"/>
+                </a:solidFill>
+                <a:latin typeface="Aptos"/>
+              </a:rPr>
+              <a:t>→</a:t>
+            </a:r>
+            <a:endParaRPr lang="en-US" sz="2200"/>
+          </a:p>
+        </p:txBody>
+      </p:sp>
+      <p:sp>
+        <p:nvSpPr>
+          <p:cNvPr id="40" name="card-40"/>
+          <p:cNvSpPr/>
+          <p:nvPr/>
+        </p:nvSpPr>
+        <p:spPr>
+          <a:xfrm>
+            <a:off x="9747504" y="3017520"/>
+            <a:ext cx="1417320" cy="1024128"/>
+          </a:xfrm>
+          <a:prstGeom prst="rect">
+            <a:avLst/>
+          </a:prstGeom>
+          <a:solidFill>
+            <a:srgbClr val="159B9A"/>
+          </a:solidFill>
+          <a:ln>
+            <a:noFill/>
+          </a:ln>
+        </p:spPr>
+      </p:sp>
+      <p:sp>
+        <p:nvSpPr>
+          <p:cNvPr id="41" name="card-text-40"/>
+          <p:cNvSpPr/>
+          <p:nvPr/>
+        </p:nvSpPr>
+        <p:spPr>
+          <a:xfrm>
+            <a:off x="9838944" y="3108960"/>
+            <a:ext cx="1234440" cy="841248"/>
+          </a:xfrm>
+          <a:prstGeom prst="rect">
+            <a:avLst/>
+          </a:prstGeom>
+          <a:noFill/>
+          <a:ln>
+            <a:noFill/>
+          </a:ln>
+        </p:spPr>
+        <p:txBody>
+          <a:bodyPr wrap="square" rtlCol="0"/>
+          <a:lstStyle/>
+          <a:p>
+            <a:pPr lvl="0">
+              <a:buNone/>
+            </a:pPr>
+            <a:r>
+              <a:rPr lang="en-US" sz="1400" b="1">
+                <a:solidFill>
+                  <a:srgbClr val="FFFFFF"/>
+                </a:solidFill>
+                <a:latin typeface="Aptos"/>
+              </a:rPr>
+              <a:t>DASHBOARD</a:t>
+            </a:r>
+            <a:endParaRPr lang="en-US" sz="1400"/>
+          </a:p>
+          <a:p>
+            <a:pPr lvl="0">
+              <a:buNone/>
+            </a:pPr>
+            <a:r>
+              <a:rPr lang="en-US" sz="900">
+                <a:solidFill>
+                  <a:srgbClr val="EAF4F5"/>
+                </a:solidFill>
+                <a:latin typeface="Aptos"/>
+              </a:rPr>
+              <a:t>replay + evidence</a:t>
+            </a:r>
+            <a:endParaRPr lang="en-US" sz="900"/>
           </a:p>
         </p:txBody>
       </p:sp>
@@ -618,8 +1460,8 @@
         </p:nvSpPr>
         <p:spPr>
           <a:xfrm>
-            <a:off x="749808" y="1261872"/>
-            <a:ext cx="10698480" cy="4800600"/>
+            <a:off x="658368" y="1261872"/>
+            <a:ext cx="3886200" cy="4800600"/>
           </a:xfrm>
           <a:prstGeom prst="rect">
             <a:avLst/>
@@ -637,7 +1479,7 @@
               <a:buChar char="•"/>
             </a:pPr>
             <a:r>
-              <a:rPr lang="en-US" sz="1700">
+              <a:rPr lang="en-US" sz="1500">
                 <a:solidFill>
                   <a:srgbClr val="26364D"/>
                 </a:solidFill>
@@ -645,14 +1487,14 @@
               </a:rPr>
               <a:t>60 patients, 5 days, 5-minute grid</a:t>
             </a:r>
-            <a:endParaRPr lang="en-US" sz="1700"/>
+            <a:endParaRPr lang="en-US" sz="1500"/>
           </a:p>
           <a:p>
             <a:pPr lvl="0">
               <a:buChar char="•"/>
             </a:pPr>
             <a:r>
-              <a:rPr lang="en-US" sz="1700">
+              <a:rPr lang="en-US" sz="1500">
                 <a:solidFill>
                   <a:srgbClr val="26364D"/>
                 </a:solidFill>
@@ -660,14 +1502,14 @@
               </a:rPr>
               <a:t>CGM, heart rate, HRV, sleep, activity, meals, and static fields</a:t>
             </a:r>
-            <a:endParaRPr lang="en-US" sz="1700"/>
+            <a:endParaRPr lang="en-US" sz="1500"/>
           </a:p>
           <a:p>
             <a:pPr lvl="0">
               <a:buChar char="•"/>
             </a:pPr>
             <a:r>
-              <a:rPr lang="en-US" sz="1700">
+              <a:rPr lang="en-US" sz="1500">
                 <a:solidFill>
                   <a:srgbClr val="26364D"/>
                 </a:solidFill>
@@ -675,14 +1517,14 @@
               </a:rPr>
               <a:t>Hidden simulator parameters never become model features</a:t>
             </a:r>
-            <a:endParaRPr lang="en-US" sz="1700"/>
+            <a:endParaRPr lang="en-US" sz="1500"/>
           </a:p>
           <a:p>
             <a:pPr lvl="0">
               <a:buChar char="•"/>
             </a:pPr>
             <a:r>
-              <a:rPr lang="en-US" sz="1700">
+              <a:rPr lang="en-US" sz="1500">
                 <a:solidFill>
                   <a:srgbClr val="26364D"/>
                 </a:solidFill>
@@ -690,7 +1532,389 @@
               </a:rPr>
               <a:t>No real patient records or public benchmark data</a:t>
             </a:r>
-            <a:endParaRPr lang="en-US" sz="1700"/>
+            <a:endParaRPr lang="en-US" sz="1500"/>
+          </a:p>
+        </p:txBody>
+      </p:sp>
+      <p:sp>
+        <p:nvSpPr>
+          <p:cNvPr id="20" name="card-20"/>
+          <p:cNvSpPr/>
+          <p:nvPr/>
+        </p:nvSpPr>
+        <p:spPr>
+          <a:xfrm>
+            <a:off x="4892040" y="1417320"/>
+            <a:ext cx="1417320" cy="1024128"/>
+          </a:xfrm>
+          <a:prstGeom prst="rect">
+            <a:avLst/>
+          </a:prstGeom>
+          <a:solidFill>
+            <a:srgbClr val="159B9A"/>
+          </a:solidFill>
+          <a:ln>
+            <a:noFill/>
+          </a:ln>
+        </p:spPr>
+      </p:sp>
+      <p:sp>
+        <p:nvSpPr>
+          <p:cNvPr id="21" name="card-text-20"/>
+          <p:cNvSpPr/>
+          <p:nvPr/>
+        </p:nvSpPr>
+        <p:spPr>
+          <a:xfrm>
+            <a:off x="4983480" y="1508760"/>
+            <a:ext cx="1234440" cy="841248"/>
+          </a:xfrm>
+          <a:prstGeom prst="rect">
+            <a:avLst/>
+          </a:prstGeom>
+          <a:noFill/>
+          <a:ln>
+            <a:noFill/>
+          </a:ln>
+        </p:spPr>
+        <p:txBody>
+          <a:bodyPr wrap="square" rtlCol="0"/>
+          <a:lstStyle/>
+          <a:p>
+            <a:pPr lvl="0">
+              <a:buNone/>
+            </a:pPr>
+            <a:r>
+              <a:rPr lang="en-US" sz="1400" b="1">
+                <a:solidFill>
+                  <a:srgbClr val="FFFFFF"/>
+                </a:solidFill>
+                <a:latin typeface="Aptos"/>
+              </a:rPr>
+              <a:t>60 PATIENTS</a:t>
+            </a:r>
+            <a:endParaRPr lang="en-US" sz="1400"/>
+          </a:p>
+          <a:p>
+            <a:pPr lvl="0">
+              <a:buNone/>
+            </a:pPr>
+            <a:r>
+              <a:rPr lang="en-US" sz="900">
+                <a:solidFill>
+                  <a:srgbClr val="EAF4F5"/>
+                </a:solidFill>
+                <a:latin typeface="Aptos"/>
+              </a:rPr>
+              <a:t>5 synthetic days</a:t>
+            </a:r>
+            <a:endParaRPr lang="en-US" sz="900"/>
+          </a:p>
+        </p:txBody>
+      </p:sp>
+      <p:sp>
+        <p:nvSpPr>
+          <p:cNvPr id="22" name="arrow-22"/>
+          <p:cNvSpPr/>
+          <p:nvPr/>
+        </p:nvSpPr>
+        <p:spPr>
+          <a:xfrm>
+            <a:off x="6318504" y="1700784"/>
+            <a:ext cx="260000" cy="430000"/>
+          </a:xfrm>
+          <a:prstGeom prst="rect">
+            <a:avLst/>
+          </a:prstGeom>
+          <a:noFill/>
+          <a:ln>
+            <a:noFill/>
+          </a:ln>
+        </p:spPr>
+        <p:txBody>
+          <a:bodyPr wrap="square" rtlCol="0"/>
+          <a:lstStyle/>
+          <a:p>
+            <a:pPr lvl="0">
+              <a:buNone/>
+            </a:pPr>
+            <a:r>
+              <a:rPr lang="en-US" sz="2200" b="1">
+                <a:solidFill>
+                  <a:srgbClr val="7667E8"/>
+                </a:solidFill>
+                <a:latin typeface="Aptos"/>
+              </a:rPr>
+              <a:t>→</a:t>
+            </a:r>
+            <a:endParaRPr lang="en-US" sz="2200"/>
+          </a:p>
+        </p:txBody>
+      </p:sp>
+      <p:sp>
+        <p:nvSpPr>
+          <p:cNvPr id="23" name="card-23"/>
+          <p:cNvSpPr/>
+          <p:nvPr/>
+        </p:nvSpPr>
+        <p:spPr>
+          <a:xfrm>
+            <a:off x="6510528" y="1417320"/>
+            <a:ext cx="1417320" cy="1024128"/>
+          </a:xfrm>
+          <a:prstGeom prst="rect">
+            <a:avLst/>
+          </a:prstGeom>
+          <a:solidFill>
+            <a:srgbClr val="7667E8"/>
+          </a:solidFill>
+          <a:ln>
+            <a:noFill/>
+          </a:ln>
+        </p:spPr>
+      </p:sp>
+      <p:sp>
+        <p:nvSpPr>
+          <p:cNvPr id="24" name="card-text-23"/>
+          <p:cNvSpPr/>
+          <p:nvPr/>
+        </p:nvSpPr>
+        <p:spPr>
+          <a:xfrm>
+            <a:off x="6601968" y="1508760"/>
+            <a:ext cx="1234440" cy="841248"/>
+          </a:xfrm>
+          <a:prstGeom prst="rect">
+            <a:avLst/>
+          </a:prstGeom>
+          <a:noFill/>
+          <a:ln>
+            <a:noFill/>
+          </a:ln>
+        </p:spPr>
+        <p:txBody>
+          <a:bodyPr wrap="square" rtlCol="0"/>
+          <a:lstStyle/>
+          <a:p>
+            <a:pPr lvl="0">
+              <a:buNone/>
+            </a:pPr>
+            <a:r>
+              <a:rPr lang="en-US" sz="1400" b="1">
+                <a:solidFill>
+                  <a:srgbClr val="FFFFFF"/>
+                </a:solidFill>
+                <a:latin typeface="Aptos"/>
+              </a:rPr>
+              <a:t>CGM</a:t>
+            </a:r>
+            <a:endParaRPr lang="en-US" sz="1400"/>
+          </a:p>
+          <a:p>
+            <a:pPr lvl="0">
+              <a:buNone/>
+            </a:pPr>
+            <a:r>
+              <a:rPr lang="en-US" sz="900">
+                <a:solidFill>
+                  <a:srgbClr val="EAF4F5"/>
+                </a:solidFill>
+                <a:latin typeface="Aptos"/>
+              </a:rPr>
+              <a:t>5-minute grid</a:t>
+            </a:r>
+            <a:endParaRPr lang="en-US" sz="900"/>
+          </a:p>
+        </p:txBody>
+      </p:sp>
+      <p:sp>
+        <p:nvSpPr>
+          <p:cNvPr id="25" name="card-25"/>
+          <p:cNvSpPr/>
+          <p:nvPr/>
+        </p:nvSpPr>
+        <p:spPr>
+          <a:xfrm>
+            <a:off x="4892040" y="3017520"/>
+            <a:ext cx="1417320" cy="1024128"/>
+          </a:xfrm>
+          <a:prstGeom prst="rect">
+            <a:avLst/>
+          </a:prstGeom>
+          <a:solidFill>
+            <a:srgbClr val="159B9A"/>
+          </a:solidFill>
+          <a:ln>
+            <a:noFill/>
+          </a:ln>
+        </p:spPr>
+      </p:sp>
+      <p:sp>
+        <p:nvSpPr>
+          <p:cNvPr id="26" name="card-text-25"/>
+          <p:cNvSpPr/>
+          <p:nvPr/>
+        </p:nvSpPr>
+        <p:spPr>
+          <a:xfrm>
+            <a:off x="4983480" y="3108960"/>
+            <a:ext cx="1234440" cy="841248"/>
+          </a:xfrm>
+          <a:prstGeom prst="rect">
+            <a:avLst/>
+          </a:prstGeom>
+          <a:noFill/>
+          <a:ln>
+            <a:noFill/>
+          </a:ln>
+        </p:spPr>
+        <p:txBody>
+          <a:bodyPr wrap="square" rtlCol="0"/>
+          <a:lstStyle/>
+          <a:p>
+            <a:pPr lvl="0">
+              <a:buNone/>
+            </a:pPr>
+            <a:r>
+              <a:rPr lang="en-US" sz="1400" b="1">
+                <a:solidFill>
+                  <a:srgbClr val="FFFFFF"/>
+                </a:solidFill>
+                <a:latin typeface="Aptos"/>
+              </a:rPr>
+              <a:t>CONTEXT</a:t>
+            </a:r>
+            <a:endParaRPr lang="en-US" sz="1400"/>
+          </a:p>
+          <a:p>
+            <a:pPr lvl="0">
+              <a:buNone/>
+            </a:pPr>
+            <a:r>
+              <a:rPr lang="en-US" sz="900">
+                <a:solidFill>
+                  <a:srgbClr val="EAF4F5"/>
+                </a:solidFill>
+                <a:latin typeface="Aptos"/>
+              </a:rPr>
+              <a:t>HR / HRV / sleep</a:t>
+            </a:r>
+            <a:endParaRPr lang="en-US" sz="900"/>
+          </a:p>
+        </p:txBody>
+      </p:sp>
+      <p:sp>
+        <p:nvSpPr>
+          <p:cNvPr id="27" name="arrow-27"/>
+          <p:cNvSpPr/>
+          <p:nvPr/>
+        </p:nvSpPr>
+        <p:spPr>
+          <a:xfrm>
+            <a:off x="6318504" y="3300984"/>
+            <a:ext cx="260000" cy="430000"/>
+          </a:xfrm>
+          <a:prstGeom prst="rect">
+            <a:avLst/>
+          </a:prstGeom>
+          <a:noFill/>
+          <a:ln>
+            <a:noFill/>
+          </a:ln>
+        </p:spPr>
+        <p:txBody>
+          <a:bodyPr wrap="square" rtlCol="0"/>
+          <a:lstStyle/>
+          <a:p>
+            <a:pPr lvl="0">
+              <a:buNone/>
+            </a:pPr>
+            <a:r>
+              <a:rPr lang="en-US" sz="2200" b="1">
+                <a:solidFill>
+                  <a:srgbClr val="7667E8"/>
+                </a:solidFill>
+                <a:latin typeface="Aptos"/>
+              </a:rPr>
+              <a:t>→</a:t>
+            </a:r>
+            <a:endParaRPr lang="en-US" sz="2200"/>
+          </a:p>
+        </p:txBody>
+      </p:sp>
+      <p:sp>
+        <p:nvSpPr>
+          <p:cNvPr id="28" name="card-28"/>
+          <p:cNvSpPr/>
+          <p:nvPr/>
+        </p:nvSpPr>
+        <p:spPr>
+          <a:xfrm>
+            <a:off x="6510528" y="3017520"/>
+            <a:ext cx="1417320" cy="1024128"/>
+          </a:xfrm>
+          <a:prstGeom prst="rect">
+            <a:avLst/>
+          </a:prstGeom>
+          <a:solidFill>
+            <a:srgbClr val="7667E8"/>
+          </a:solidFill>
+          <a:ln>
+            <a:noFill/>
+          </a:ln>
+        </p:spPr>
+      </p:sp>
+      <p:sp>
+        <p:nvSpPr>
+          <p:cNvPr id="29" name="card-text-28"/>
+          <p:cNvSpPr/>
+          <p:nvPr/>
+        </p:nvSpPr>
+        <p:spPr>
+          <a:xfrm>
+            <a:off x="6601968" y="3108960"/>
+            <a:ext cx="1234440" cy="841248"/>
+          </a:xfrm>
+          <a:prstGeom prst="rect">
+            <a:avLst/>
+          </a:prstGeom>
+          <a:noFill/>
+          <a:ln>
+            <a:noFill/>
+          </a:ln>
+        </p:spPr>
+        <p:txBody>
+          <a:bodyPr wrap="square" rtlCol="0"/>
+          <a:lstStyle/>
+          <a:p>
+            <a:pPr lvl="0">
+              <a:buNone/>
+            </a:pPr>
+            <a:r>
+              <a:rPr lang="en-US" sz="1400" b="1">
+                <a:solidFill>
+                  <a:srgbClr val="FFFFFF"/>
+                </a:solidFill>
+                <a:latin typeface="Aptos"/>
+              </a:rPr>
+              <a:t>MEALS + ACTIVITY</a:t>
+            </a:r>
+            <a:endParaRPr lang="en-US" sz="1400"/>
+          </a:p>
+          <a:p>
+            <a:pPr lvl="0">
+              <a:buNone/>
+            </a:pPr>
+            <a:r>
+              <a:rPr lang="en-US" sz="900">
+                <a:solidFill>
+                  <a:srgbClr val="EAF4F5"/>
+                </a:solidFill>
+                <a:latin typeface="Aptos"/>
+              </a:rPr>
+              <a:t>observed streams</a:t>
+            </a:r>
+            <a:endParaRPr lang="en-US" sz="900"/>
           </a:p>
         </p:txBody>
       </p:sp>
@@ -849,8 +2073,8 @@
         </p:nvSpPr>
         <p:spPr>
           <a:xfrm>
-            <a:off x="749808" y="1261872"/>
-            <a:ext cx="10698480" cy="4800600"/>
+            <a:off x="658368" y="1261872"/>
+            <a:ext cx="3886200" cy="4800600"/>
           </a:xfrm>
           <a:prstGeom prst="rect">
             <a:avLst/>
@@ -868,7 +2092,7 @@
               <a:buChar char="•"/>
             </a:pPr>
             <a:r>
-              <a:rPr lang="en-US" sz="1700">
+              <a:rPr lang="en-US" sz="1500">
                 <a:solidFill>
                   <a:srgbClr val="26364D"/>
                 </a:solidFill>
@@ -876,14 +2100,14 @@
               </a:rPr>
               <a:t>36 train patients; 6 calibration-tuning; 6 calibration-interval; 12 test</a:t>
             </a:r>
-            <a:endParaRPr lang="en-US" sz="1700"/>
+            <a:endParaRPr lang="en-US" sz="1500"/>
           </a:p>
           <a:p>
             <a:pPr lvl="0">
               <a:buChar char="•"/>
             </a:pPr>
             <a:r>
-              <a:rPr lang="en-US" sz="1700">
+              <a:rPr lang="en-US" sz="1500">
                 <a:solidFill>
                   <a:srgbClr val="26364D"/>
                 </a:solidFill>
@@ -891,14 +2115,14 @@
               </a:rPr>
               <a:t>No test patient tunes models, calibration, thresholds, or intervals</a:t>
             </a:r>
-            <a:endParaRPr lang="en-US" sz="1700"/>
+            <a:endParaRPr lang="en-US" sz="1500"/>
           </a:p>
           <a:p>
             <a:pPr lvl="0">
               <a:buChar char="•"/>
             </a:pPr>
             <a:r>
-              <a:rPr lang="en-US" sz="1700">
+              <a:rPr lang="en-US" sz="1500">
                 <a:solidFill>
                   <a:srgbClr val="26364D"/>
                 </a:solidFill>
@@ -906,14 +2130,14 @@
               </a:rPr>
               <a:t>Every feature vector is bounded by its replay anchor</a:t>
             </a:r>
-            <a:endParaRPr lang="en-US" sz="1700"/>
+            <a:endParaRPr lang="en-US" sz="1500"/>
           </a:p>
           <a:p>
             <a:pPr lvl="0">
               <a:buChar char="•"/>
             </a:pPr>
             <a:r>
-              <a:rPr lang="en-US" sz="1700">
+              <a:rPr lang="en-US" sz="1500">
                 <a:solidFill>
                   <a:srgbClr val="26364D"/>
                 </a:solidFill>
@@ -921,7 +2145,504 @@
               </a:rPr>
               <a:t>Correlated replay windows are not independent subjects</a:t>
             </a:r>
-            <a:endParaRPr lang="en-US" sz="1700"/>
+            <a:endParaRPr lang="en-US" sz="1500"/>
+          </a:p>
+        </p:txBody>
+      </p:sp>
+      <p:sp>
+        <p:nvSpPr>
+          <p:cNvPr id="20" name="card-20"/>
+          <p:cNvSpPr/>
+          <p:nvPr/>
+        </p:nvSpPr>
+        <p:spPr>
+          <a:xfrm>
+            <a:off x="4892040" y="1417320"/>
+            <a:ext cx="1417320" cy="1024128"/>
+          </a:xfrm>
+          <a:prstGeom prst="rect">
+            <a:avLst/>
+          </a:prstGeom>
+          <a:solidFill>
+            <a:srgbClr val="159B9A"/>
+          </a:solidFill>
+          <a:ln>
+            <a:noFill/>
+          </a:ln>
+        </p:spPr>
+      </p:sp>
+      <p:sp>
+        <p:nvSpPr>
+          <p:cNvPr id="21" name="card-text-20"/>
+          <p:cNvSpPr/>
+          <p:nvPr/>
+        </p:nvSpPr>
+        <p:spPr>
+          <a:xfrm>
+            <a:off x="4983480" y="1508760"/>
+            <a:ext cx="1234440" cy="841248"/>
+          </a:xfrm>
+          <a:prstGeom prst="rect">
+            <a:avLst/>
+          </a:prstGeom>
+          <a:noFill/>
+          <a:ln>
+            <a:noFill/>
+          </a:ln>
+        </p:spPr>
+        <p:txBody>
+          <a:bodyPr wrap="square" rtlCol="0"/>
+          <a:lstStyle/>
+          <a:p>
+            <a:pPr lvl="0">
+              <a:buNone/>
+            </a:pPr>
+            <a:r>
+              <a:rPr lang="en-US" sz="1400" b="1">
+                <a:solidFill>
+                  <a:srgbClr val="FFFFFF"/>
+                </a:solidFill>
+                <a:latin typeface="Aptos"/>
+              </a:rPr>
+              <a:t>TRAIN</a:t>
+            </a:r>
+            <a:endParaRPr lang="en-US" sz="1400"/>
+          </a:p>
+          <a:p>
+            <a:pPr lvl="0">
+              <a:buNone/>
+            </a:pPr>
+            <a:r>
+              <a:rPr lang="en-US" sz="900">
+                <a:solidFill>
+                  <a:srgbClr val="EAF4F5"/>
+                </a:solidFill>
+                <a:latin typeface="Aptos"/>
+              </a:rPr>
+              <a:t>36 patients</a:t>
+            </a:r>
+            <a:endParaRPr lang="en-US" sz="900"/>
+          </a:p>
+        </p:txBody>
+      </p:sp>
+      <p:sp>
+        <p:nvSpPr>
+          <p:cNvPr id="22" name="arrow-22"/>
+          <p:cNvSpPr/>
+          <p:nvPr/>
+        </p:nvSpPr>
+        <p:spPr>
+          <a:xfrm>
+            <a:off x="6318504" y="1700784"/>
+            <a:ext cx="260000" cy="430000"/>
+          </a:xfrm>
+          <a:prstGeom prst="rect">
+            <a:avLst/>
+          </a:prstGeom>
+          <a:noFill/>
+          <a:ln>
+            <a:noFill/>
+          </a:ln>
+        </p:spPr>
+        <p:txBody>
+          <a:bodyPr wrap="square" rtlCol="0"/>
+          <a:lstStyle/>
+          <a:p>
+            <a:pPr lvl="0">
+              <a:buNone/>
+            </a:pPr>
+            <a:r>
+              <a:rPr lang="en-US" sz="2200" b="1">
+                <a:solidFill>
+                  <a:srgbClr val="7667E8"/>
+                </a:solidFill>
+                <a:latin typeface="Aptos"/>
+              </a:rPr>
+              <a:t>→</a:t>
+            </a:r>
+            <a:endParaRPr lang="en-US" sz="2200"/>
+          </a:p>
+        </p:txBody>
+      </p:sp>
+      <p:sp>
+        <p:nvSpPr>
+          <p:cNvPr id="23" name="card-23"/>
+          <p:cNvSpPr/>
+          <p:nvPr/>
+        </p:nvSpPr>
+        <p:spPr>
+          <a:xfrm>
+            <a:off x="6510528" y="1417320"/>
+            <a:ext cx="1417320" cy="1024128"/>
+          </a:xfrm>
+          <a:prstGeom prst="rect">
+            <a:avLst/>
+          </a:prstGeom>
+          <a:solidFill>
+            <a:srgbClr val="7667E8"/>
+          </a:solidFill>
+          <a:ln>
+            <a:noFill/>
+          </a:ln>
+        </p:spPr>
+      </p:sp>
+      <p:sp>
+        <p:nvSpPr>
+          <p:cNvPr id="24" name="card-text-23"/>
+          <p:cNvSpPr/>
+          <p:nvPr/>
+        </p:nvSpPr>
+        <p:spPr>
+          <a:xfrm>
+            <a:off x="6601968" y="1508760"/>
+            <a:ext cx="1234440" cy="841248"/>
+          </a:xfrm>
+          <a:prstGeom prst="rect">
+            <a:avLst/>
+          </a:prstGeom>
+          <a:noFill/>
+          <a:ln>
+            <a:noFill/>
+          </a:ln>
+        </p:spPr>
+        <p:txBody>
+          <a:bodyPr wrap="square" rtlCol="0"/>
+          <a:lstStyle/>
+          <a:p>
+            <a:pPr lvl="0">
+              <a:buNone/>
+            </a:pPr>
+            <a:r>
+              <a:rPr lang="en-US" sz="1400" b="1">
+                <a:solidFill>
+                  <a:srgbClr val="FFFFFF"/>
+                </a:solidFill>
+                <a:latin typeface="Aptos"/>
+              </a:rPr>
+              <a:t>TUNE</a:t>
+            </a:r>
+            <a:endParaRPr lang="en-US" sz="1400"/>
+          </a:p>
+          <a:p>
+            <a:pPr lvl="0">
+              <a:buNone/>
+            </a:pPr>
+            <a:r>
+              <a:rPr lang="en-US" sz="900">
+                <a:solidFill>
+                  <a:srgbClr val="EAF4F5"/>
+                </a:solidFill>
+                <a:latin typeface="Aptos"/>
+              </a:rPr>
+              <a:t>6 patients</a:t>
+            </a:r>
+            <a:endParaRPr lang="en-US" sz="900"/>
+          </a:p>
+        </p:txBody>
+      </p:sp>
+      <p:sp>
+        <p:nvSpPr>
+          <p:cNvPr id="25" name="arrow-25"/>
+          <p:cNvSpPr/>
+          <p:nvPr/>
+        </p:nvSpPr>
+        <p:spPr>
+          <a:xfrm>
+            <a:off x="7936992" y="1700784"/>
+            <a:ext cx="260000" cy="430000"/>
+          </a:xfrm>
+          <a:prstGeom prst="rect">
+            <a:avLst/>
+          </a:prstGeom>
+          <a:noFill/>
+          <a:ln>
+            <a:noFill/>
+          </a:ln>
+        </p:spPr>
+        <p:txBody>
+          <a:bodyPr wrap="square" rtlCol="0"/>
+          <a:lstStyle/>
+          <a:p>
+            <a:pPr lvl="0">
+              <a:buNone/>
+            </a:pPr>
+            <a:r>
+              <a:rPr lang="en-US" sz="2200" b="1">
+                <a:solidFill>
+                  <a:srgbClr val="7667E8"/>
+                </a:solidFill>
+                <a:latin typeface="Aptos"/>
+              </a:rPr>
+              <a:t>→</a:t>
+            </a:r>
+            <a:endParaRPr lang="en-US" sz="2200"/>
+          </a:p>
+        </p:txBody>
+      </p:sp>
+      <p:sp>
+        <p:nvSpPr>
+          <p:cNvPr id="26" name="card-26"/>
+          <p:cNvSpPr/>
+          <p:nvPr/>
+        </p:nvSpPr>
+        <p:spPr>
+          <a:xfrm>
+            <a:off x="8129016" y="1417320"/>
+            <a:ext cx="1417320" cy="1024128"/>
+          </a:xfrm>
+          <a:prstGeom prst="rect">
+            <a:avLst/>
+          </a:prstGeom>
+          <a:solidFill>
+            <a:srgbClr val="159B9A"/>
+          </a:solidFill>
+          <a:ln>
+            <a:noFill/>
+          </a:ln>
+        </p:spPr>
+      </p:sp>
+      <p:sp>
+        <p:nvSpPr>
+          <p:cNvPr id="27" name="card-text-26"/>
+          <p:cNvSpPr/>
+          <p:nvPr/>
+        </p:nvSpPr>
+        <p:spPr>
+          <a:xfrm>
+            <a:off x="8220456" y="1508760"/>
+            <a:ext cx="1234440" cy="841248"/>
+          </a:xfrm>
+          <a:prstGeom prst="rect">
+            <a:avLst/>
+          </a:prstGeom>
+          <a:noFill/>
+          <a:ln>
+            <a:noFill/>
+          </a:ln>
+        </p:spPr>
+        <p:txBody>
+          <a:bodyPr wrap="square" rtlCol="0"/>
+          <a:lstStyle/>
+          <a:p>
+            <a:pPr lvl="0">
+              <a:buNone/>
+            </a:pPr>
+            <a:r>
+              <a:rPr lang="en-US" sz="1400" b="1">
+                <a:solidFill>
+                  <a:srgbClr val="FFFFFF"/>
+                </a:solidFill>
+                <a:latin typeface="Aptos"/>
+              </a:rPr>
+              <a:t>INTERVAL</a:t>
+            </a:r>
+            <a:endParaRPr lang="en-US" sz="1400"/>
+          </a:p>
+          <a:p>
+            <a:pPr lvl="0">
+              <a:buNone/>
+            </a:pPr>
+            <a:r>
+              <a:rPr lang="en-US" sz="900">
+                <a:solidFill>
+                  <a:srgbClr val="EAF4F5"/>
+                </a:solidFill>
+                <a:latin typeface="Aptos"/>
+              </a:rPr>
+              <a:t>6 patients</a:t>
+            </a:r>
+            <a:endParaRPr lang="en-US" sz="900"/>
+          </a:p>
+        </p:txBody>
+      </p:sp>
+      <p:sp>
+        <p:nvSpPr>
+          <p:cNvPr id="28" name="arrow-28"/>
+          <p:cNvSpPr/>
+          <p:nvPr/>
+        </p:nvSpPr>
+        <p:spPr>
+          <a:xfrm>
+            <a:off x="9555480" y="1700784"/>
+            <a:ext cx="260000" cy="430000"/>
+          </a:xfrm>
+          <a:prstGeom prst="rect">
+            <a:avLst/>
+          </a:prstGeom>
+          <a:noFill/>
+          <a:ln>
+            <a:noFill/>
+          </a:ln>
+        </p:spPr>
+        <p:txBody>
+          <a:bodyPr wrap="square" rtlCol="0"/>
+          <a:lstStyle/>
+          <a:p>
+            <a:pPr lvl="0">
+              <a:buNone/>
+            </a:pPr>
+            <a:r>
+              <a:rPr lang="en-US" sz="2200" b="1">
+                <a:solidFill>
+                  <a:srgbClr val="7667E8"/>
+                </a:solidFill>
+                <a:latin typeface="Aptos"/>
+              </a:rPr>
+              <a:t>→</a:t>
+            </a:r>
+            <a:endParaRPr lang="en-US" sz="2200"/>
+          </a:p>
+        </p:txBody>
+      </p:sp>
+      <p:sp>
+        <p:nvSpPr>
+          <p:cNvPr id="29" name="card-29"/>
+          <p:cNvSpPr/>
+          <p:nvPr/>
+        </p:nvSpPr>
+        <p:spPr>
+          <a:xfrm>
+            <a:off x="9747504" y="1417320"/>
+            <a:ext cx="1417320" cy="1024128"/>
+          </a:xfrm>
+          <a:prstGeom prst="rect">
+            <a:avLst/>
+          </a:prstGeom>
+          <a:solidFill>
+            <a:srgbClr val="D58A36"/>
+          </a:solidFill>
+          <a:ln>
+            <a:noFill/>
+          </a:ln>
+        </p:spPr>
+      </p:sp>
+      <p:sp>
+        <p:nvSpPr>
+          <p:cNvPr id="30" name="card-text-29"/>
+          <p:cNvSpPr/>
+          <p:nvPr/>
+        </p:nvSpPr>
+        <p:spPr>
+          <a:xfrm>
+            <a:off x="9838944" y="1508760"/>
+            <a:ext cx="1234440" cy="841248"/>
+          </a:xfrm>
+          <a:prstGeom prst="rect">
+            <a:avLst/>
+          </a:prstGeom>
+          <a:noFill/>
+          <a:ln>
+            <a:noFill/>
+          </a:ln>
+        </p:spPr>
+        <p:txBody>
+          <a:bodyPr wrap="square" rtlCol="0"/>
+          <a:lstStyle/>
+          <a:p>
+            <a:pPr lvl="0">
+              <a:buNone/>
+            </a:pPr>
+            <a:r>
+              <a:rPr lang="en-US" sz="1400" b="1">
+                <a:solidFill>
+                  <a:srgbClr val="FFFFFF"/>
+                </a:solidFill>
+                <a:latin typeface="Aptos"/>
+              </a:rPr>
+              <a:t>TEST</a:t>
+            </a:r>
+            <a:endParaRPr lang="en-US" sz="1400"/>
+          </a:p>
+          <a:p>
+            <a:pPr lvl="0">
+              <a:buNone/>
+            </a:pPr>
+            <a:r>
+              <a:rPr lang="en-US" sz="900">
+                <a:solidFill>
+                  <a:srgbClr val="EAF4F5"/>
+                </a:solidFill>
+                <a:latin typeface="Aptos"/>
+              </a:rPr>
+              <a:t>12 held-out</a:t>
+            </a:r>
+            <a:endParaRPr lang="en-US" sz="900"/>
+          </a:p>
+        </p:txBody>
+      </p:sp>
+      <p:sp>
+        <p:nvSpPr>
+          <p:cNvPr id="31" name="card-31"/>
+          <p:cNvSpPr/>
+          <p:nvPr/>
+        </p:nvSpPr>
+        <p:spPr>
+          <a:xfrm>
+            <a:off x="4892040" y="3017520"/>
+            <a:ext cx="6309360" cy="1024128"/>
+          </a:xfrm>
+          <a:prstGeom prst="rect">
+            <a:avLst/>
+          </a:prstGeom>
+          <a:solidFill>
+            <a:srgbClr val="14253D"/>
+          </a:solidFill>
+          <a:ln>
+            <a:noFill/>
+          </a:ln>
+        </p:spPr>
+      </p:sp>
+      <p:sp>
+        <p:nvSpPr>
+          <p:cNvPr id="32" name="card-text-31"/>
+          <p:cNvSpPr/>
+          <p:nvPr/>
+        </p:nvSpPr>
+        <p:spPr>
+          <a:xfrm>
+            <a:off x="4983480" y="3108960"/>
+            <a:ext cx="6126480" cy="841248"/>
+          </a:xfrm>
+          <a:prstGeom prst="rect">
+            <a:avLst/>
+          </a:prstGeom>
+          <a:noFill/>
+          <a:ln>
+            <a:noFill/>
+          </a:ln>
+        </p:spPr>
+        <p:txBody>
+          <a:bodyPr wrap="square" rtlCol="0"/>
+          <a:lstStyle/>
+          <a:p>
+            <a:pPr lvl="0">
+              <a:buNone/>
+            </a:pPr>
+            <a:r>
+              <a:rPr lang="en-US" sz="1400" b="1">
+                <a:solidFill>
+                  <a:srgbClr val="FFFFFF"/>
+                </a:solidFill>
+                <a:latin typeface="Aptos"/>
+              </a:rPr>
+              <a:t>RULE</a:t>
+            </a:r>
+            <a:endParaRPr lang="en-US" sz="1400"/>
+          </a:p>
+          <a:p>
+            <a:pPr lvl="0">
+              <a:buNone/>
+            </a:pPr>
+            <a:r>
+              <a:rPr lang="en-US" sz="900">
+                <a:solidFill>
+                  <a:srgbClr val="EAF4F5"/>
+                </a:solidFill>
+                <a:latin typeface="Aptos"/>
+              </a:rPr>
+              <a:t>No test patient chooses a model setting; features stop at the replay anchor.</a:t>
+            </a:r>
+            <a:endParaRPr lang="en-US" sz="900"/>
           </a:p>
         </p:txBody>
       </p:sp>
@@ -1080,8 +2801,8 @@
         </p:nvSpPr>
         <p:spPr>
           <a:xfrm>
-            <a:off x="749808" y="1261872"/>
-            <a:ext cx="10698480" cy="4800600"/>
+            <a:off x="658368" y="1261872"/>
+            <a:ext cx="3886200" cy="4800600"/>
           </a:xfrm>
           <a:prstGeom prst="rect">
             <a:avLst/>
@@ -1099,7 +2820,7 @@
               <a:buChar char="•"/>
             </a:pPr>
             <a:r>
-              <a:rPr lang="en-US" sz="1700">
+              <a:rPr lang="en-US" sz="1500">
                 <a:solidFill>
                   <a:srgbClr val="26364D"/>
                 </a:solidFill>
@@ -1107,14 +2828,14 @@
               </a:rPr>
               <a:t>Temporal lag gradient-boosting heads for glucose</a:t>
             </a:r>
-            <a:endParaRPr lang="en-US" sz="1700"/>
+            <a:endParaRPr lang="en-US" sz="1500"/>
           </a:p>
           <a:p>
             <a:pPr lvl="0">
               <a:buChar char="•"/>
             </a:pPr>
             <a:r>
-              <a:rPr lang="en-US" sz="1700">
+              <a:rPr lang="en-US" sz="1500">
                 <a:solidFill>
                   <a:srgbClr val="26364D"/>
                 </a:solidFill>
@@ -1122,14 +2843,14 @@
               </a:rPr>
               <a:t>Fusion logistic classifier for the sustained-event endpoint</a:t>
             </a:r>
-            <a:endParaRPr lang="en-US" sz="1700"/>
+            <a:endParaRPr lang="en-US" sz="1500"/>
           </a:p>
           <a:p>
             <a:pPr lvl="0">
               <a:buChar char="•"/>
             </a:pPr>
             <a:r>
-              <a:rPr lang="en-US" sz="1700">
+              <a:rPr lang="en-US" sz="1500">
                 <a:solidFill>
                   <a:srgbClr val="26364D"/>
                 </a:solidFill>
@@ -1137,14 +2858,14 @@
               </a:rPr>
               <a:t>Train-only imputation, standardization, and missing indicators</a:t>
             </a:r>
-            <a:endParaRPr lang="en-US" sz="1700"/>
+            <a:endParaRPr lang="en-US" sz="1500"/>
           </a:p>
           <a:p>
             <a:pPr lvl="0">
               <a:buChar char="•"/>
             </a:pPr>
             <a:r>
-              <a:rPr lang="en-US" sz="1700">
+              <a:rPr lang="en-US" sz="1500">
                 <a:solidFill>
                   <a:srgbClr val="26364D"/>
                 </a:solidFill>
@@ -1152,7 +2873,504 @@
               </a:rPr>
               <a:t>Platt probability calibration and split-conformal intervals</a:t>
             </a:r>
-            <a:endParaRPr lang="en-US" sz="1700"/>
+            <a:endParaRPr lang="en-US" sz="1500"/>
+          </a:p>
+        </p:txBody>
+      </p:sp>
+      <p:sp>
+        <p:nvSpPr>
+          <p:cNvPr id="20" name="card-20"/>
+          <p:cNvSpPr/>
+          <p:nvPr/>
+        </p:nvSpPr>
+        <p:spPr>
+          <a:xfrm>
+            <a:off x="4892040" y="1417320"/>
+            <a:ext cx="1417320" cy="1024128"/>
+          </a:xfrm>
+          <a:prstGeom prst="rect">
+            <a:avLst/>
+          </a:prstGeom>
+          <a:solidFill>
+            <a:srgbClr val="159B9A"/>
+          </a:solidFill>
+          <a:ln>
+            <a:noFill/>
+          </a:ln>
+        </p:spPr>
+      </p:sp>
+      <p:sp>
+        <p:nvSpPr>
+          <p:cNvPr id="21" name="card-text-20"/>
+          <p:cNvSpPr/>
+          <p:nvPr/>
+        </p:nvSpPr>
+        <p:spPr>
+          <a:xfrm>
+            <a:off x="4983480" y="1508760"/>
+            <a:ext cx="1234440" cy="841248"/>
+          </a:xfrm>
+          <a:prstGeom prst="rect">
+            <a:avLst/>
+          </a:prstGeom>
+          <a:noFill/>
+          <a:ln>
+            <a:noFill/>
+          </a:ln>
+        </p:spPr>
+        <p:txBody>
+          <a:bodyPr wrap="square" rtlCol="0"/>
+          <a:lstStyle/>
+          <a:p>
+            <a:pPr lvl="0">
+              <a:buNone/>
+            </a:pPr>
+            <a:r>
+              <a:rPr lang="en-US" sz="1400" b="1">
+                <a:solidFill>
+                  <a:srgbClr val="FFFFFF"/>
+                </a:solidFill>
+                <a:latin typeface="Aptos"/>
+              </a:rPr>
+              <a:t>FEATURES</a:t>
+            </a:r>
+            <a:endParaRPr lang="en-US" sz="1400"/>
+          </a:p>
+          <a:p>
+            <a:pPr lvl="0">
+              <a:buNone/>
+            </a:pPr>
+            <a:r>
+              <a:rPr lang="en-US" sz="900">
+                <a:solidFill>
+                  <a:srgbClr val="EAF4F5"/>
+                </a:solidFill>
+                <a:latin typeface="Aptos"/>
+              </a:rPr>
+              <a:t>lags + context</a:t>
+            </a:r>
+            <a:endParaRPr lang="en-US" sz="900"/>
+          </a:p>
+        </p:txBody>
+      </p:sp>
+      <p:sp>
+        <p:nvSpPr>
+          <p:cNvPr id="22" name="arrow-22"/>
+          <p:cNvSpPr/>
+          <p:nvPr/>
+        </p:nvSpPr>
+        <p:spPr>
+          <a:xfrm>
+            <a:off x="6318504" y="1700784"/>
+            <a:ext cx="260000" cy="430000"/>
+          </a:xfrm>
+          <a:prstGeom prst="rect">
+            <a:avLst/>
+          </a:prstGeom>
+          <a:noFill/>
+          <a:ln>
+            <a:noFill/>
+          </a:ln>
+        </p:spPr>
+        <p:txBody>
+          <a:bodyPr wrap="square" rtlCol="0"/>
+          <a:lstStyle/>
+          <a:p>
+            <a:pPr lvl="0">
+              <a:buNone/>
+            </a:pPr>
+            <a:r>
+              <a:rPr lang="en-US" sz="2200" b="1">
+                <a:solidFill>
+                  <a:srgbClr val="7667E8"/>
+                </a:solidFill>
+                <a:latin typeface="Aptos"/>
+              </a:rPr>
+              <a:t>→</a:t>
+            </a:r>
+            <a:endParaRPr lang="en-US" sz="2200"/>
+          </a:p>
+        </p:txBody>
+      </p:sp>
+      <p:sp>
+        <p:nvSpPr>
+          <p:cNvPr id="23" name="card-23"/>
+          <p:cNvSpPr/>
+          <p:nvPr/>
+        </p:nvSpPr>
+        <p:spPr>
+          <a:xfrm>
+            <a:off x="6510528" y="1417320"/>
+            <a:ext cx="1417320" cy="1024128"/>
+          </a:xfrm>
+          <a:prstGeom prst="rect">
+            <a:avLst/>
+          </a:prstGeom>
+          <a:solidFill>
+            <a:srgbClr val="7667E8"/>
+          </a:solidFill>
+          <a:ln>
+            <a:noFill/>
+          </a:ln>
+        </p:spPr>
+      </p:sp>
+      <p:sp>
+        <p:nvSpPr>
+          <p:cNvPr id="24" name="card-text-23"/>
+          <p:cNvSpPr/>
+          <p:nvPr/>
+        </p:nvSpPr>
+        <p:spPr>
+          <a:xfrm>
+            <a:off x="6601968" y="1508760"/>
+            <a:ext cx="1234440" cy="841248"/>
+          </a:xfrm>
+          <a:prstGeom prst="rect">
+            <a:avLst/>
+          </a:prstGeom>
+          <a:noFill/>
+          <a:ln>
+            <a:noFill/>
+          </a:ln>
+        </p:spPr>
+        <p:txBody>
+          <a:bodyPr wrap="square" rtlCol="0"/>
+          <a:lstStyle/>
+          <a:p>
+            <a:pPr lvl="0">
+              <a:buNone/>
+            </a:pPr>
+            <a:r>
+              <a:rPr lang="en-US" sz="1400" b="1">
+                <a:solidFill>
+                  <a:srgbClr val="FFFFFF"/>
+                </a:solidFill>
+                <a:latin typeface="Aptos"/>
+              </a:rPr>
+              <a:t>TEMPORAL</a:t>
+            </a:r>
+            <a:endParaRPr lang="en-US" sz="1400"/>
+          </a:p>
+          <a:p>
+            <a:pPr lvl="0">
+              <a:buNone/>
+            </a:pPr>
+            <a:r>
+              <a:rPr lang="en-US" sz="900">
+                <a:solidFill>
+                  <a:srgbClr val="EAF4F5"/>
+                </a:solidFill>
+                <a:latin typeface="Aptos"/>
+              </a:rPr>
+              <a:t>glucose heads</a:t>
+            </a:r>
+            <a:endParaRPr lang="en-US" sz="900"/>
+          </a:p>
+        </p:txBody>
+      </p:sp>
+      <p:sp>
+        <p:nvSpPr>
+          <p:cNvPr id="25" name="arrow-25"/>
+          <p:cNvSpPr/>
+          <p:nvPr/>
+        </p:nvSpPr>
+        <p:spPr>
+          <a:xfrm>
+            <a:off x="7936992" y="1700784"/>
+            <a:ext cx="260000" cy="430000"/>
+          </a:xfrm>
+          <a:prstGeom prst="rect">
+            <a:avLst/>
+          </a:prstGeom>
+          <a:noFill/>
+          <a:ln>
+            <a:noFill/>
+          </a:ln>
+        </p:spPr>
+        <p:txBody>
+          <a:bodyPr wrap="square" rtlCol="0"/>
+          <a:lstStyle/>
+          <a:p>
+            <a:pPr lvl="0">
+              <a:buNone/>
+            </a:pPr>
+            <a:r>
+              <a:rPr lang="en-US" sz="2200" b="1">
+                <a:solidFill>
+                  <a:srgbClr val="7667E8"/>
+                </a:solidFill>
+                <a:latin typeface="Aptos"/>
+              </a:rPr>
+              <a:t>→</a:t>
+            </a:r>
+            <a:endParaRPr lang="en-US" sz="2200"/>
+          </a:p>
+        </p:txBody>
+      </p:sp>
+      <p:sp>
+        <p:nvSpPr>
+          <p:cNvPr id="26" name="card-26"/>
+          <p:cNvSpPr/>
+          <p:nvPr/>
+        </p:nvSpPr>
+        <p:spPr>
+          <a:xfrm>
+            <a:off x="8129016" y="1417320"/>
+            <a:ext cx="1417320" cy="1024128"/>
+          </a:xfrm>
+          <a:prstGeom prst="rect">
+            <a:avLst/>
+          </a:prstGeom>
+          <a:solidFill>
+            <a:srgbClr val="159B9A"/>
+          </a:solidFill>
+          <a:ln>
+            <a:noFill/>
+          </a:ln>
+        </p:spPr>
+      </p:sp>
+      <p:sp>
+        <p:nvSpPr>
+          <p:cNvPr id="27" name="card-text-26"/>
+          <p:cNvSpPr/>
+          <p:nvPr/>
+        </p:nvSpPr>
+        <p:spPr>
+          <a:xfrm>
+            <a:off x="8220456" y="1508760"/>
+            <a:ext cx="1234440" cy="841248"/>
+          </a:xfrm>
+          <a:prstGeom prst="rect">
+            <a:avLst/>
+          </a:prstGeom>
+          <a:noFill/>
+          <a:ln>
+            <a:noFill/>
+          </a:ln>
+        </p:spPr>
+        <p:txBody>
+          <a:bodyPr wrap="square" rtlCol="0"/>
+          <a:lstStyle/>
+          <a:p>
+            <a:pPr lvl="0">
+              <a:buNone/>
+            </a:pPr>
+            <a:r>
+              <a:rPr lang="en-US" sz="1400" b="1">
+                <a:solidFill>
+                  <a:srgbClr val="FFFFFF"/>
+                </a:solidFill>
+                <a:latin typeface="Aptos"/>
+              </a:rPr>
+              <a:t>EVENT</a:t>
+            </a:r>
+            <a:endParaRPr lang="en-US" sz="1400"/>
+          </a:p>
+          <a:p>
+            <a:pPr lvl="0">
+              <a:buNone/>
+            </a:pPr>
+            <a:r>
+              <a:rPr lang="en-US" sz="900">
+                <a:solidFill>
+                  <a:srgbClr val="EAF4F5"/>
+                </a:solidFill>
+                <a:latin typeface="Aptos"/>
+              </a:rPr>
+              <a:t>fusion risk</a:t>
+            </a:r>
+            <a:endParaRPr lang="en-US" sz="900"/>
+          </a:p>
+        </p:txBody>
+      </p:sp>
+      <p:sp>
+        <p:nvSpPr>
+          <p:cNvPr id="28" name="arrow-28"/>
+          <p:cNvSpPr/>
+          <p:nvPr/>
+        </p:nvSpPr>
+        <p:spPr>
+          <a:xfrm>
+            <a:off x="9555480" y="1700784"/>
+            <a:ext cx="260000" cy="430000"/>
+          </a:xfrm>
+          <a:prstGeom prst="rect">
+            <a:avLst/>
+          </a:prstGeom>
+          <a:noFill/>
+          <a:ln>
+            <a:noFill/>
+          </a:ln>
+        </p:spPr>
+        <p:txBody>
+          <a:bodyPr wrap="square" rtlCol="0"/>
+          <a:lstStyle/>
+          <a:p>
+            <a:pPr lvl="0">
+              <a:buNone/>
+            </a:pPr>
+            <a:r>
+              <a:rPr lang="en-US" sz="2200" b="1">
+                <a:solidFill>
+                  <a:srgbClr val="7667E8"/>
+                </a:solidFill>
+                <a:latin typeface="Aptos"/>
+              </a:rPr>
+              <a:t>→</a:t>
+            </a:r>
+            <a:endParaRPr lang="en-US" sz="2200"/>
+          </a:p>
+        </p:txBody>
+      </p:sp>
+      <p:sp>
+        <p:nvSpPr>
+          <p:cNvPr id="29" name="card-29"/>
+          <p:cNvSpPr/>
+          <p:nvPr/>
+        </p:nvSpPr>
+        <p:spPr>
+          <a:xfrm>
+            <a:off x="9747504" y="1417320"/>
+            <a:ext cx="1417320" cy="1024128"/>
+          </a:xfrm>
+          <a:prstGeom prst="rect">
+            <a:avLst/>
+          </a:prstGeom>
+          <a:solidFill>
+            <a:srgbClr val="7667E8"/>
+          </a:solidFill>
+          <a:ln>
+            <a:noFill/>
+          </a:ln>
+        </p:spPr>
+      </p:sp>
+      <p:sp>
+        <p:nvSpPr>
+          <p:cNvPr id="30" name="card-text-29"/>
+          <p:cNvSpPr/>
+          <p:nvPr/>
+        </p:nvSpPr>
+        <p:spPr>
+          <a:xfrm>
+            <a:off x="9838944" y="1508760"/>
+            <a:ext cx="1234440" cy="841248"/>
+          </a:xfrm>
+          <a:prstGeom prst="rect">
+            <a:avLst/>
+          </a:prstGeom>
+          <a:noFill/>
+          <a:ln>
+            <a:noFill/>
+          </a:ln>
+        </p:spPr>
+        <p:txBody>
+          <a:bodyPr wrap="square" rtlCol="0"/>
+          <a:lstStyle/>
+          <a:p>
+            <a:pPr lvl="0">
+              <a:buNone/>
+            </a:pPr>
+            <a:r>
+              <a:rPr lang="en-US" sz="1400" b="1">
+                <a:solidFill>
+                  <a:srgbClr val="FFFFFF"/>
+                </a:solidFill>
+                <a:latin typeface="Aptos"/>
+              </a:rPr>
+              <a:t>CALIBRATE</a:t>
+            </a:r>
+            <a:endParaRPr lang="en-US" sz="1400"/>
+          </a:p>
+          <a:p>
+            <a:pPr lvl="0">
+              <a:buNone/>
+            </a:pPr>
+            <a:r>
+              <a:rPr lang="en-US" sz="900">
+                <a:solidFill>
+                  <a:srgbClr val="EAF4F5"/>
+                </a:solidFill>
+                <a:latin typeface="Aptos"/>
+              </a:rPr>
+              <a:t>honest intervals</a:t>
+            </a:r>
+            <a:endParaRPr lang="en-US" sz="900"/>
+          </a:p>
+        </p:txBody>
+      </p:sp>
+      <p:sp>
+        <p:nvSpPr>
+          <p:cNvPr id="31" name="card-31"/>
+          <p:cNvSpPr/>
+          <p:nvPr/>
+        </p:nvSpPr>
+        <p:spPr>
+          <a:xfrm>
+            <a:off x="4892040" y="3017520"/>
+            <a:ext cx="6309360" cy="1024128"/>
+          </a:xfrm>
+          <a:prstGeom prst="rect">
+            <a:avLst/>
+          </a:prstGeom>
+          <a:solidFill>
+            <a:srgbClr val="14253D"/>
+          </a:solidFill>
+          <a:ln>
+            <a:noFill/>
+          </a:ln>
+        </p:spPr>
+      </p:sp>
+      <p:sp>
+        <p:nvSpPr>
+          <p:cNvPr id="32" name="card-text-31"/>
+          <p:cNvSpPr/>
+          <p:nvPr/>
+        </p:nvSpPr>
+        <p:spPr>
+          <a:xfrm>
+            <a:off x="4983480" y="3108960"/>
+            <a:ext cx="6126480" cy="841248"/>
+          </a:xfrm>
+          <a:prstGeom prst="rect">
+            <a:avLst/>
+          </a:prstGeom>
+          <a:noFill/>
+          <a:ln>
+            <a:noFill/>
+          </a:ln>
+        </p:spPr>
+        <p:txBody>
+          <a:bodyPr wrap="square" rtlCol="0"/>
+          <a:lstStyle/>
+          <a:p>
+            <a:pPr lvl="0">
+              <a:buNone/>
+            </a:pPr>
+            <a:r>
+              <a:rPr lang="en-US" sz="1400" b="1">
+                <a:solidFill>
+                  <a:srgbClr val="FFFFFF"/>
+                </a:solidFill>
+                <a:latin typeface="Aptos"/>
+              </a:rPr>
+              <a:t>OUTPUT</a:t>
+            </a:r>
+            <a:endParaRPr lang="en-US" sz="1400"/>
+          </a:p>
+          <a:p>
+            <a:pPr lvl="0">
+              <a:buNone/>
+            </a:pPr>
+            <a:r>
+              <a:rPr lang="en-US" sz="900">
+                <a:solidFill>
+                  <a:srgbClr val="EAF4F5"/>
+                </a:solidFill>
+                <a:latin typeface="Aptos"/>
+              </a:rPr>
+              <a:t>30 / 60 / 120-minute heads + risk + reason + provenance</a:t>
+            </a:r>
+            <a:endParaRPr lang="en-US" sz="900"/>
           </a:p>
         </p:txBody>
       </p:sp>
@@ -1311,8 +3529,8 @@
         </p:nvSpPr>
         <p:spPr>
           <a:xfrm>
-            <a:off x="749808" y="1261872"/>
-            <a:ext cx="10698480" cy="4800600"/>
+            <a:off x="658368" y="1261872"/>
+            <a:ext cx="3886200" cy="4800600"/>
           </a:xfrm>
           <a:prstGeom prst="rect">
             <a:avLst/>
@@ -1330,7 +3548,7 @@
               <a:buChar char="•"/>
             </a:pPr>
             <a:r>
-              <a:rPr lang="en-US" sz="1700">
+              <a:rPr lang="en-US" sz="1500">
                 <a:solidFill>
                   <a:srgbClr val="26364D"/>
                 </a:solidFill>
@@ -1338,14 +3556,14 @@
               </a:rPr>
               <a:t>A prior forecast error is used only after its target timestamp is observable</a:t>
             </a:r>
-            <a:endParaRPr lang="en-US" sz="1700"/>
+            <a:endParaRPr lang="en-US" sz="1500"/>
           </a:p>
           <a:p>
             <a:pPr lvl="0">
               <a:buChar char="•"/>
             </a:pPr>
             <a:r>
-              <a:rPr lang="en-US" sz="1700">
+              <a:rPr lang="en-US" sz="1500">
                 <a:solidFill>
                   <a:srgbClr val="26364D"/>
                 </a:solidFill>
@@ -1353,14 +3571,14 @@
               </a:rPr>
               <a:t>Per-patient, short, bounded error history</a:t>
             </a:r>
-            <a:endParaRPr lang="en-US" sz="1700"/>
+            <a:endParaRPr lang="en-US" sz="1500"/>
           </a:p>
           <a:p>
             <a:pPr lvl="0">
               <a:buChar char="•"/>
             </a:pPr>
             <a:r>
-              <a:rPr lang="en-US" sz="1700">
+              <a:rPr lang="en-US" sz="1500">
                 <a:solidFill>
                   <a:srgbClr val="26364D"/>
                 </a:solidFill>
@@ -1368,14 +3586,14 @@
               </a:rPr>
               <a:t>Strength selected on calibration-tuning patients</a:t>
             </a:r>
-            <a:endParaRPr lang="en-US" sz="1700"/>
+            <a:endParaRPr lang="en-US" sz="1500"/>
           </a:p>
           <a:p>
             <a:pPr lvl="0">
               <a:buChar char="•"/>
             </a:pPr>
             <a:r>
-              <a:rPr lang="en-US" sz="1700">
+              <a:rPr lang="en-US" sz="1500">
                 <a:solidFill>
                   <a:srgbClr val="26364D"/>
                 </a:solidFill>
@@ -1383,7 +3601,504 @@
               </a:rPr>
               <a:t>Adaptive residual only - not a clinical insulin-sensitivity model</a:t>
             </a:r>
-            <a:endParaRPr lang="en-US" sz="1700"/>
+            <a:endParaRPr lang="en-US" sz="1500"/>
+          </a:p>
+        </p:txBody>
+      </p:sp>
+      <p:sp>
+        <p:nvSpPr>
+          <p:cNvPr id="20" name="card-20"/>
+          <p:cNvSpPr/>
+          <p:nvPr/>
+        </p:nvSpPr>
+        <p:spPr>
+          <a:xfrm>
+            <a:off x="4892040" y="1417320"/>
+            <a:ext cx="1417320" cy="1024128"/>
+          </a:xfrm>
+          <a:prstGeom prst="rect">
+            <a:avLst/>
+          </a:prstGeom>
+          <a:solidFill>
+            <a:srgbClr val="159B9A"/>
+          </a:solidFill>
+          <a:ln>
+            <a:noFill/>
+          </a:ln>
+        </p:spPr>
+      </p:sp>
+      <p:sp>
+        <p:nvSpPr>
+          <p:cNvPr id="21" name="card-text-20"/>
+          <p:cNvSpPr/>
+          <p:nvPr/>
+        </p:nvSpPr>
+        <p:spPr>
+          <a:xfrm>
+            <a:off x="4983480" y="1508760"/>
+            <a:ext cx="1234440" cy="841248"/>
+          </a:xfrm>
+          <a:prstGeom prst="rect">
+            <a:avLst/>
+          </a:prstGeom>
+          <a:noFill/>
+          <a:ln>
+            <a:noFill/>
+          </a:ln>
+        </p:spPr>
+        <p:txBody>
+          <a:bodyPr wrap="square" rtlCol="0"/>
+          <a:lstStyle/>
+          <a:p>
+            <a:pPr lvl="0">
+              <a:buNone/>
+            </a:pPr>
+            <a:r>
+              <a:rPr lang="en-US" sz="1400" b="1">
+                <a:solidFill>
+                  <a:srgbClr val="FFFFFF"/>
+                </a:solidFill>
+                <a:latin typeface="Aptos"/>
+              </a:rPr>
+              <a:t>T</a:t>
+            </a:r>
+            <a:endParaRPr lang="en-US" sz="1400"/>
+          </a:p>
+          <a:p>
+            <a:pPr lvl="0">
+              <a:buNone/>
+            </a:pPr>
+            <a:r>
+              <a:rPr lang="en-US" sz="900">
+                <a:solidFill>
+                  <a:srgbClr val="EAF4F5"/>
+                </a:solidFill>
+                <a:latin typeface="Aptos"/>
+              </a:rPr>
+              <a:t>forecast</a:t>
+            </a:r>
+            <a:endParaRPr lang="en-US" sz="900"/>
+          </a:p>
+        </p:txBody>
+      </p:sp>
+      <p:sp>
+        <p:nvSpPr>
+          <p:cNvPr id="22" name="arrow-22"/>
+          <p:cNvSpPr/>
+          <p:nvPr/>
+        </p:nvSpPr>
+        <p:spPr>
+          <a:xfrm>
+            <a:off x="6318504" y="1700784"/>
+            <a:ext cx="260000" cy="430000"/>
+          </a:xfrm>
+          <a:prstGeom prst="rect">
+            <a:avLst/>
+          </a:prstGeom>
+          <a:noFill/>
+          <a:ln>
+            <a:noFill/>
+          </a:ln>
+        </p:spPr>
+        <p:txBody>
+          <a:bodyPr wrap="square" rtlCol="0"/>
+          <a:lstStyle/>
+          <a:p>
+            <a:pPr lvl="0">
+              <a:buNone/>
+            </a:pPr>
+            <a:r>
+              <a:rPr lang="en-US" sz="2200" b="1">
+                <a:solidFill>
+                  <a:srgbClr val="7667E8"/>
+                </a:solidFill>
+                <a:latin typeface="Aptos"/>
+              </a:rPr>
+              <a:t>→</a:t>
+            </a:r>
+            <a:endParaRPr lang="en-US" sz="2200"/>
+          </a:p>
+        </p:txBody>
+      </p:sp>
+      <p:sp>
+        <p:nvSpPr>
+          <p:cNvPr id="23" name="card-23"/>
+          <p:cNvSpPr/>
+          <p:nvPr/>
+        </p:nvSpPr>
+        <p:spPr>
+          <a:xfrm>
+            <a:off x="6510528" y="1417320"/>
+            <a:ext cx="1417320" cy="1024128"/>
+          </a:xfrm>
+          <a:prstGeom prst="rect">
+            <a:avLst/>
+          </a:prstGeom>
+          <a:solidFill>
+            <a:srgbClr val="7667E8"/>
+          </a:solidFill>
+          <a:ln>
+            <a:noFill/>
+          </a:ln>
+        </p:spPr>
+      </p:sp>
+      <p:sp>
+        <p:nvSpPr>
+          <p:cNvPr id="24" name="card-text-23"/>
+          <p:cNvSpPr/>
+          <p:nvPr/>
+        </p:nvSpPr>
+        <p:spPr>
+          <a:xfrm>
+            <a:off x="6601968" y="1508760"/>
+            <a:ext cx="1234440" cy="841248"/>
+          </a:xfrm>
+          <a:prstGeom prst="rect">
+            <a:avLst/>
+          </a:prstGeom>
+          <a:noFill/>
+          <a:ln>
+            <a:noFill/>
+          </a:ln>
+        </p:spPr>
+        <p:txBody>
+          <a:bodyPr wrap="square" rtlCol="0"/>
+          <a:lstStyle/>
+          <a:p>
+            <a:pPr lvl="0">
+              <a:buNone/>
+            </a:pPr>
+            <a:r>
+              <a:rPr lang="en-US" sz="1400" b="1">
+                <a:solidFill>
+                  <a:srgbClr val="FFFFFF"/>
+                </a:solidFill>
+                <a:latin typeface="Aptos"/>
+              </a:rPr>
+              <a:t>TARGET</a:t>
+            </a:r>
+            <a:endParaRPr lang="en-US" sz="1400"/>
+          </a:p>
+          <a:p>
+            <a:pPr lvl="0">
+              <a:buNone/>
+            </a:pPr>
+            <a:r>
+              <a:rPr lang="en-US" sz="900">
+                <a:solidFill>
+                  <a:srgbClr val="EAF4F5"/>
+                </a:solidFill>
+                <a:latin typeface="Aptos"/>
+              </a:rPr>
+              <a:t>time arrives</a:t>
+            </a:r>
+            <a:endParaRPr lang="en-US" sz="900"/>
+          </a:p>
+        </p:txBody>
+      </p:sp>
+      <p:sp>
+        <p:nvSpPr>
+          <p:cNvPr id="25" name="arrow-25"/>
+          <p:cNvSpPr/>
+          <p:nvPr/>
+        </p:nvSpPr>
+        <p:spPr>
+          <a:xfrm>
+            <a:off x="7936992" y="1700784"/>
+            <a:ext cx="260000" cy="430000"/>
+          </a:xfrm>
+          <a:prstGeom prst="rect">
+            <a:avLst/>
+          </a:prstGeom>
+          <a:noFill/>
+          <a:ln>
+            <a:noFill/>
+          </a:ln>
+        </p:spPr>
+        <p:txBody>
+          <a:bodyPr wrap="square" rtlCol="0"/>
+          <a:lstStyle/>
+          <a:p>
+            <a:pPr lvl="0">
+              <a:buNone/>
+            </a:pPr>
+            <a:r>
+              <a:rPr lang="en-US" sz="2200" b="1">
+                <a:solidFill>
+                  <a:srgbClr val="7667E8"/>
+                </a:solidFill>
+                <a:latin typeface="Aptos"/>
+              </a:rPr>
+              <a:t>→</a:t>
+            </a:r>
+            <a:endParaRPr lang="en-US" sz="2200"/>
+          </a:p>
+        </p:txBody>
+      </p:sp>
+      <p:sp>
+        <p:nvSpPr>
+          <p:cNvPr id="26" name="card-26"/>
+          <p:cNvSpPr/>
+          <p:nvPr/>
+        </p:nvSpPr>
+        <p:spPr>
+          <a:xfrm>
+            <a:off x="8129016" y="1417320"/>
+            <a:ext cx="1417320" cy="1024128"/>
+          </a:xfrm>
+          <a:prstGeom prst="rect">
+            <a:avLst/>
+          </a:prstGeom>
+          <a:solidFill>
+            <a:srgbClr val="159B9A"/>
+          </a:solidFill>
+          <a:ln>
+            <a:noFill/>
+          </a:ln>
+        </p:spPr>
+      </p:sp>
+      <p:sp>
+        <p:nvSpPr>
+          <p:cNvPr id="27" name="card-text-26"/>
+          <p:cNvSpPr/>
+          <p:nvPr/>
+        </p:nvSpPr>
+        <p:spPr>
+          <a:xfrm>
+            <a:off x="8220456" y="1508760"/>
+            <a:ext cx="1234440" cy="841248"/>
+          </a:xfrm>
+          <a:prstGeom prst="rect">
+            <a:avLst/>
+          </a:prstGeom>
+          <a:noFill/>
+          <a:ln>
+            <a:noFill/>
+          </a:ln>
+        </p:spPr>
+        <p:txBody>
+          <a:bodyPr wrap="square" rtlCol="0"/>
+          <a:lstStyle/>
+          <a:p>
+            <a:pPr lvl="0">
+              <a:buNone/>
+            </a:pPr>
+            <a:r>
+              <a:rPr lang="en-US" sz="1400" b="1">
+                <a:solidFill>
+                  <a:srgbClr val="FFFFFF"/>
+                </a:solidFill>
+                <a:latin typeface="Aptos"/>
+              </a:rPr>
+              <a:t>ERROR</a:t>
+            </a:r>
+            <a:endParaRPr lang="en-US" sz="1400"/>
+          </a:p>
+          <a:p>
+            <a:pPr lvl="0">
+              <a:buNone/>
+            </a:pPr>
+            <a:r>
+              <a:rPr lang="en-US" sz="900">
+                <a:solidFill>
+                  <a:srgbClr val="EAF4F5"/>
+                </a:solidFill>
+                <a:latin typeface="Aptos"/>
+              </a:rPr>
+              <a:t>observed</a:t>
+            </a:r>
+            <a:endParaRPr lang="en-US" sz="900"/>
+          </a:p>
+        </p:txBody>
+      </p:sp>
+      <p:sp>
+        <p:nvSpPr>
+          <p:cNvPr id="28" name="arrow-28"/>
+          <p:cNvSpPr/>
+          <p:nvPr/>
+        </p:nvSpPr>
+        <p:spPr>
+          <a:xfrm>
+            <a:off x="9555480" y="1700784"/>
+            <a:ext cx="260000" cy="430000"/>
+          </a:xfrm>
+          <a:prstGeom prst="rect">
+            <a:avLst/>
+          </a:prstGeom>
+          <a:noFill/>
+          <a:ln>
+            <a:noFill/>
+          </a:ln>
+        </p:spPr>
+        <p:txBody>
+          <a:bodyPr wrap="square" rtlCol="0"/>
+          <a:lstStyle/>
+          <a:p>
+            <a:pPr lvl="0">
+              <a:buNone/>
+            </a:pPr>
+            <a:r>
+              <a:rPr lang="en-US" sz="2200" b="1">
+                <a:solidFill>
+                  <a:srgbClr val="7667E8"/>
+                </a:solidFill>
+                <a:latin typeface="Aptos"/>
+              </a:rPr>
+              <a:t>→</a:t>
+            </a:r>
+            <a:endParaRPr lang="en-US" sz="2200"/>
+          </a:p>
+        </p:txBody>
+      </p:sp>
+      <p:sp>
+        <p:nvSpPr>
+          <p:cNvPr id="29" name="card-29"/>
+          <p:cNvSpPr/>
+          <p:nvPr/>
+        </p:nvSpPr>
+        <p:spPr>
+          <a:xfrm>
+            <a:off x="9747504" y="1417320"/>
+            <a:ext cx="1417320" cy="1024128"/>
+          </a:xfrm>
+          <a:prstGeom prst="rect">
+            <a:avLst/>
+          </a:prstGeom>
+          <a:solidFill>
+            <a:srgbClr val="7667E8"/>
+          </a:solidFill>
+          <a:ln>
+            <a:noFill/>
+          </a:ln>
+        </p:spPr>
+      </p:sp>
+      <p:sp>
+        <p:nvSpPr>
+          <p:cNvPr id="30" name="card-text-29"/>
+          <p:cNvSpPr/>
+          <p:nvPr/>
+        </p:nvSpPr>
+        <p:spPr>
+          <a:xfrm>
+            <a:off x="9838944" y="1508760"/>
+            <a:ext cx="1234440" cy="841248"/>
+          </a:xfrm>
+          <a:prstGeom prst="rect">
+            <a:avLst/>
+          </a:prstGeom>
+          <a:noFill/>
+          <a:ln>
+            <a:noFill/>
+          </a:ln>
+        </p:spPr>
+        <p:txBody>
+          <a:bodyPr wrap="square" rtlCol="0"/>
+          <a:lstStyle/>
+          <a:p>
+            <a:pPr lvl="0">
+              <a:buNone/>
+            </a:pPr>
+            <a:r>
+              <a:rPr lang="en-US" sz="1400" b="1">
+                <a:solidFill>
+                  <a:srgbClr val="FFFFFF"/>
+                </a:solidFill>
+                <a:latin typeface="Aptos"/>
+              </a:rPr>
+              <a:t>T+1</a:t>
+            </a:r>
+            <a:endParaRPr lang="en-US" sz="1400"/>
+          </a:p>
+          <a:p>
+            <a:pPr lvl="0">
+              <a:buNone/>
+            </a:pPr>
+            <a:r>
+              <a:rPr lang="en-US" sz="900">
+                <a:solidFill>
+                  <a:srgbClr val="EAF4F5"/>
+                </a:solidFill>
+                <a:latin typeface="Aptos"/>
+              </a:rPr>
+              <a:t>bounded update</a:t>
+            </a:r>
+            <a:endParaRPr lang="en-US" sz="900"/>
+          </a:p>
+        </p:txBody>
+      </p:sp>
+      <p:sp>
+        <p:nvSpPr>
+          <p:cNvPr id="31" name="card-31"/>
+          <p:cNvSpPr/>
+          <p:nvPr/>
+        </p:nvSpPr>
+        <p:spPr>
+          <a:xfrm>
+            <a:off x="4892040" y="3017520"/>
+            <a:ext cx="6309360" cy="1024128"/>
+          </a:xfrm>
+          <a:prstGeom prst="rect">
+            <a:avLst/>
+          </a:prstGeom>
+          <a:solidFill>
+            <a:srgbClr val="14253D"/>
+          </a:solidFill>
+          <a:ln>
+            <a:noFill/>
+          </a:ln>
+        </p:spPr>
+      </p:sp>
+      <p:sp>
+        <p:nvSpPr>
+          <p:cNvPr id="32" name="card-text-31"/>
+          <p:cNvSpPr/>
+          <p:nvPr/>
+        </p:nvSpPr>
+        <p:spPr>
+          <a:xfrm>
+            <a:off x="4983480" y="3108960"/>
+            <a:ext cx="6126480" cy="841248"/>
+          </a:xfrm>
+          <a:prstGeom prst="rect">
+            <a:avLst/>
+          </a:prstGeom>
+          <a:noFill/>
+          <a:ln>
+            <a:noFill/>
+          </a:ln>
+        </p:spPr>
+        <p:txBody>
+          <a:bodyPr wrap="square" rtlCol="0"/>
+          <a:lstStyle/>
+          <a:p>
+            <a:pPr lvl="0">
+              <a:buNone/>
+            </a:pPr>
+            <a:r>
+              <a:rPr lang="en-US" sz="1400" b="1">
+                <a:solidFill>
+                  <a:srgbClr val="FFFFFF"/>
+                </a:solidFill>
+                <a:latin typeface="Aptos"/>
+              </a:rPr>
+              <a:t>GUARDRAIL</a:t>
+            </a:r>
+            <a:endParaRPr lang="en-US" sz="1400"/>
+          </a:p>
+          <a:p>
+            <a:pPr lvl="0">
+              <a:buNone/>
+            </a:pPr>
+            <a:r>
+              <a:rPr lang="en-US" sz="900">
+                <a:solidFill>
+                  <a:srgbClr val="EAF4F5"/>
+                </a:solidFill>
+                <a:latin typeface="Aptos"/>
+              </a:rPr>
+              <a:t>Future target cannot influence its own forecast. Adaptive residual != physiology.</a:t>
+            </a:r>
+            <a:endParaRPr lang="en-US" sz="900"/>
           </a:p>
         </p:txBody>
       </p:sp>
@@ -1542,8 +4257,8 @@
         </p:nvSpPr>
         <p:spPr>
           <a:xfrm>
-            <a:off x="749808" y="1261872"/>
-            <a:ext cx="10698480" cy="4800600"/>
+            <a:off x="658368" y="1261872"/>
+            <a:ext cx="3886200" cy="4800600"/>
           </a:xfrm>
           <a:prstGeom prst="rect">
             <a:avLst/>
@@ -1561,7 +4276,7 @@
               <a:buChar char="•"/>
             </a:pPr>
             <a:r>
-              <a:rPr lang="en-US" sz="1700">
+              <a:rPr lang="en-US" sz="1500">
                 <a:solidFill>
                   <a:srgbClr val="26364D"/>
                 </a:solidFill>
@@ -1569,14 +4284,14 @@
               </a:rPr>
               <a:t>TwinEngine loads artifacts and never trains during API requests</a:t>
             </a:r>
-            <a:endParaRPr lang="en-US" sz="1700"/>
+            <a:endParaRPr lang="en-US" sz="1500"/>
           </a:p>
           <a:p>
             <a:pPr lvl="0">
               <a:buChar char="•"/>
             </a:pPr>
             <a:r>
-              <a:rPr lang="en-US" sz="1700">
+              <a:rPr lang="en-US" sz="1500">
                 <a:solidFill>
                   <a:srgbClr val="26364D"/>
                 </a:solidFill>
@@ -1584,14 +4299,14 @@
               </a:rPr>
               <a:t>Local endpoints: health, patients, twin snapshot, scenario, metrics</a:t>
             </a:r>
-            <a:endParaRPr lang="en-US" sz="1700"/>
+            <a:endParaRPr lang="en-US" sz="1500"/>
           </a:p>
           <a:p>
             <a:pPr lvl="0">
               <a:buChar char="•"/>
             </a:pPr>
             <a:r>
-              <a:rPr lang="en-US" sz="1700">
+              <a:rPr lang="en-US" sz="1500">
                 <a:solidFill>
                   <a:srgbClr val="26364D"/>
                 </a:solidFill>
@@ -1599,14 +4314,14 @@
               </a:rPr>
               <a:t>Missing/stale CGM produces warnings and abstention</a:t>
             </a:r>
-            <a:endParaRPr lang="en-US" sz="1700"/>
+            <a:endParaRPr lang="en-US" sz="1500"/>
           </a:p>
           <a:p>
             <a:pPr lvl="0">
               <a:buChar char="•"/>
             </a:pPr>
             <a:r>
-              <a:rPr lang="en-US" sz="1700">
+              <a:rPr lang="en-US" sz="1500">
                 <a:solidFill>
                   <a:srgbClr val="26364D"/>
                 </a:solidFill>
@@ -1614,7 +4329,428 @@
               </a:rPr>
               <a:t>No fallback medical numbers are inserted</a:t>
             </a:r>
-            <a:endParaRPr lang="en-US" sz="1700"/>
+            <a:endParaRPr lang="en-US" sz="1500"/>
+          </a:p>
+        </p:txBody>
+      </p:sp>
+      <p:sp>
+        <p:nvSpPr>
+          <p:cNvPr id="20" name="card-20"/>
+          <p:cNvSpPr/>
+          <p:nvPr/>
+        </p:nvSpPr>
+        <p:spPr>
+          <a:xfrm>
+            <a:off x="4892040" y="1417320"/>
+            <a:ext cx="1417320" cy="1024128"/>
+          </a:xfrm>
+          <a:prstGeom prst="rect">
+            <a:avLst/>
+          </a:prstGeom>
+          <a:solidFill>
+            <a:srgbClr val="159B9A"/>
+          </a:solidFill>
+          <a:ln>
+            <a:noFill/>
+          </a:ln>
+        </p:spPr>
+      </p:sp>
+      <p:sp>
+        <p:nvSpPr>
+          <p:cNvPr id="21" name="card-text-20"/>
+          <p:cNvSpPr/>
+          <p:nvPr/>
+        </p:nvSpPr>
+        <p:spPr>
+          <a:xfrm>
+            <a:off x="4983480" y="1508760"/>
+            <a:ext cx="1234440" cy="841248"/>
+          </a:xfrm>
+          <a:prstGeom prst="rect">
+            <a:avLst/>
+          </a:prstGeom>
+          <a:noFill/>
+          <a:ln>
+            <a:noFill/>
+          </a:ln>
+        </p:spPr>
+        <p:txBody>
+          <a:bodyPr wrap="square" rtlCol="0"/>
+          <a:lstStyle/>
+          <a:p>
+            <a:pPr lvl="0">
+              <a:buNone/>
+            </a:pPr>
+            <a:r>
+              <a:rPr lang="en-US" sz="1400" b="1">
+                <a:solidFill>
+                  <a:srgbClr val="FFFFFF"/>
+                </a:solidFill>
+                <a:latin typeface="Aptos"/>
+              </a:rPr>
+              <a:t>BUNDLE</a:t>
+            </a:r>
+            <a:endParaRPr lang="en-US" sz="1400"/>
+          </a:p>
+          <a:p>
+            <a:pPr lvl="0">
+              <a:buNone/>
+            </a:pPr>
+            <a:r>
+              <a:rPr lang="en-US" sz="900">
+                <a:solidFill>
+                  <a:srgbClr val="EAF4F5"/>
+                </a:solidFill>
+                <a:latin typeface="Aptos"/>
+              </a:rPr>
+              <a:t>joblib + JSON</a:t>
+            </a:r>
+            <a:endParaRPr lang="en-US" sz="900"/>
+          </a:p>
+        </p:txBody>
+      </p:sp>
+      <p:sp>
+        <p:nvSpPr>
+          <p:cNvPr id="22" name="arrow-22"/>
+          <p:cNvSpPr/>
+          <p:nvPr/>
+        </p:nvSpPr>
+        <p:spPr>
+          <a:xfrm>
+            <a:off x="6318504" y="1700784"/>
+            <a:ext cx="260000" cy="430000"/>
+          </a:xfrm>
+          <a:prstGeom prst="rect">
+            <a:avLst/>
+          </a:prstGeom>
+          <a:noFill/>
+          <a:ln>
+            <a:noFill/>
+          </a:ln>
+        </p:spPr>
+        <p:txBody>
+          <a:bodyPr wrap="square" rtlCol="0"/>
+          <a:lstStyle/>
+          <a:p>
+            <a:pPr lvl="0">
+              <a:buNone/>
+            </a:pPr>
+            <a:r>
+              <a:rPr lang="en-US" sz="2200" b="1">
+                <a:solidFill>
+                  <a:srgbClr val="7667E8"/>
+                </a:solidFill>
+                <a:latin typeface="Aptos"/>
+              </a:rPr>
+              <a:t>→</a:t>
+            </a:r>
+            <a:endParaRPr lang="en-US" sz="2200"/>
+          </a:p>
+        </p:txBody>
+      </p:sp>
+      <p:sp>
+        <p:nvSpPr>
+          <p:cNvPr id="23" name="card-23"/>
+          <p:cNvSpPr/>
+          <p:nvPr/>
+        </p:nvSpPr>
+        <p:spPr>
+          <a:xfrm>
+            <a:off x="6510528" y="1417320"/>
+            <a:ext cx="1417320" cy="1024128"/>
+          </a:xfrm>
+          <a:prstGeom prst="rect">
+            <a:avLst/>
+          </a:prstGeom>
+          <a:solidFill>
+            <a:srgbClr val="7667E8"/>
+          </a:solidFill>
+          <a:ln>
+            <a:noFill/>
+          </a:ln>
+        </p:spPr>
+      </p:sp>
+      <p:sp>
+        <p:nvSpPr>
+          <p:cNvPr id="24" name="card-text-23"/>
+          <p:cNvSpPr/>
+          <p:nvPr/>
+        </p:nvSpPr>
+        <p:spPr>
+          <a:xfrm>
+            <a:off x="6601968" y="1508760"/>
+            <a:ext cx="1234440" cy="841248"/>
+          </a:xfrm>
+          <a:prstGeom prst="rect">
+            <a:avLst/>
+          </a:prstGeom>
+          <a:noFill/>
+          <a:ln>
+            <a:noFill/>
+          </a:ln>
+        </p:spPr>
+        <p:txBody>
+          <a:bodyPr wrap="square" rtlCol="0"/>
+          <a:lstStyle/>
+          <a:p>
+            <a:pPr lvl="0">
+              <a:buNone/>
+            </a:pPr>
+            <a:r>
+              <a:rPr lang="en-US" sz="1400" b="1">
+                <a:solidFill>
+                  <a:srgbClr val="FFFFFF"/>
+                </a:solidFill>
+                <a:latin typeface="Aptos"/>
+              </a:rPr>
+              <a:t>ENGINE</a:t>
+            </a:r>
+            <a:endParaRPr lang="en-US" sz="1400"/>
+          </a:p>
+          <a:p>
+            <a:pPr lvl="0">
+              <a:buNone/>
+            </a:pPr>
+            <a:r>
+              <a:rPr lang="en-US" sz="900">
+                <a:solidFill>
+                  <a:srgbClr val="EAF4F5"/>
+                </a:solidFill>
+                <a:latin typeface="Aptos"/>
+              </a:rPr>
+              <a:t>no training</a:t>
+            </a:r>
+            <a:endParaRPr lang="en-US" sz="900"/>
+          </a:p>
+        </p:txBody>
+      </p:sp>
+      <p:sp>
+        <p:nvSpPr>
+          <p:cNvPr id="25" name="arrow-25"/>
+          <p:cNvSpPr/>
+          <p:nvPr/>
+        </p:nvSpPr>
+        <p:spPr>
+          <a:xfrm>
+            <a:off x="7936992" y="1700784"/>
+            <a:ext cx="260000" cy="430000"/>
+          </a:xfrm>
+          <a:prstGeom prst="rect">
+            <a:avLst/>
+          </a:prstGeom>
+          <a:noFill/>
+          <a:ln>
+            <a:noFill/>
+          </a:ln>
+        </p:spPr>
+        <p:txBody>
+          <a:bodyPr wrap="square" rtlCol="0"/>
+          <a:lstStyle/>
+          <a:p>
+            <a:pPr lvl="0">
+              <a:buNone/>
+            </a:pPr>
+            <a:r>
+              <a:rPr lang="en-US" sz="2200" b="1">
+                <a:solidFill>
+                  <a:srgbClr val="7667E8"/>
+                </a:solidFill>
+                <a:latin typeface="Aptos"/>
+              </a:rPr>
+              <a:t>→</a:t>
+            </a:r>
+            <a:endParaRPr lang="en-US" sz="2200"/>
+          </a:p>
+        </p:txBody>
+      </p:sp>
+      <p:sp>
+        <p:nvSpPr>
+          <p:cNvPr id="26" name="card-26"/>
+          <p:cNvSpPr/>
+          <p:nvPr/>
+        </p:nvSpPr>
+        <p:spPr>
+          <a:xfrm>
+            <a:off x="8129016" y="1417320"/>
+            <a:ext cx="1417320" cy="1024128"/>
+          </a:xfrm>
+          <a:prstGeom prst="rect">
+            <a:avLst/>
+          </a:prstGeom>
+          <a:solidFill>
+            <a:srgbClr val="159B9A"/>
+          </a:solidFill>
+          <a:ln>
+            <a:noFill/>
+          </a:ln>
+        </p:spPr>
+      </p:sp>
+      <p:sp>
+        <p:nvSpPr>
+          <p:cNvPr id="27" name="card-text-26"/>
+          <p:cNvSpPr/>
+          <p:nvPr/>
+        </p:nvSpPr>
+        <p:spPr>
+          <a:xfrm>
+            <a:off x="8220456" y="1508760"/>
+            <a:ext cx="1234440" cy="841248"/>
+          </a:xfrm>
+          <a:prstGeom prst="rect">
+            <a:avLst/>
+          </a:prstGeom>
+          <a:noFill/>
+          <a:ln>
+            <a:noFill/>
+          </a:ln>
+        </p:spPr>
+        <p:txBody>
+          <a:bodyPr wrap="square" rtlCol="0"/>
+          <a:lstStyle/>
+          <a:p>
+            <a:pPr lvl="0">
+              <a:buNone/>
+            </a:pPr>
+            <a:r>
+              <a:rPr lang="en-US" sz="1400" b="1">
+                <a:solidFill>
+                  <a:srgbClr val="FFFFFF"/>
+                </a:solidFill>
+                <a:latin typeface="Aptos"/>
+              </a:rPr>
+              <a:t>API</a:t>
+            </a:r>
+            <a:endParaRPr lang="en-US" sz="1400"/>
+          </a:p>
+          <a:p>
+            <a:pPr lvl="0">
+              <a:buNone/>
+            </a:pPr>
+            <a:r>
+              <a:rPr lang="en-US" sz="900">
+                <a:solidFill>
+                  <a:srgbClr val="EAF4F5"/>
+                </a:solidFill>
+                <a:latin typeface="Aptos"/>
+              </a:rPr>
+              <a:t>127.0.0.1</a:t>
+            </a:r>
+            <a:endParaRPr lang="en-US" sz="900"/>
+          </a:p>
+        </p:txBody>
+      </p:sp>
+      <p:sp>
+        <p:nvSpPr>
+          <p:cNvPr id="28" name="arrow-28"/>
+          <p:cNvSpPr/>
+          <p:nvPr/>
+        </p:nvSpPr>
+        <p:spPr>
+          <a:xfrm>
+            <a:off x="9555480" y="1700784"/>
+            <a:ext cx="260000" cy="430000"/>
+          </a:xfrm>
+          <a:prstGeom prst="rect">
+            <a:avLst/>
+          </a:prstGeom>
+          <a:noFill/>
+          <a:ln>
+            <a:noFill/>
+          </a:ln>
+        </p:spPr>
+        <p:txBody>
+          <a:bodyPr wrap="square" rtlCol="0"/>
+          <a:lstStyle/>
+          <a:p>
+            <a:pPr lvl="0">
+              <a:buNone/>
+            </a:pPr>
+            <a:r>
+              <a:rPr lang="en-US" sz="2200" b="1">
+                <a:solidFill>
+                  <a:srgbClr val="7667E8"/>
+                </a:solidFill>
+                <a:latin typeface="Aptos"/>
+              </a:rPr>
+              <a:t>→</a:t>
+            </a:r>
+            <a:endParaRPr lang="en-US" sz="2200"/>
+          </a:p>
+        </p:txBody>
+      </p:sp>
+      <p:sp>
+        <p:nvSpPr>
+          <p:cNvPr id="29" name="card-29"/>
+          <p:cNvSpPr/>
+          <p:nvPr/>
+        </p:nvSpPr>
+        <p:spPr>
+          <a:xfrm>
+            <a:off x="9747504" y="1417320"/>
+            <a:ext cx="1417320" cy="1024128"/>
+          </a:xfrm>
+          <a:prstGeom prst="rect">
+            <a:avLst/>
+          </a:prstGeom>
+          <a:solidFill>
+            <a:srgbClr val="7667E8"/>
+          </a:solidFill>
+          <a:ln>
+            <a:noFill/>
+          </a:ln>
+        </p:spPr>
+      </p:sp>
+      <p:sp>
+        <p:nvSpPr>
+          <p:cNvPr id="30" name="card-text-29"/>
+          <p:cNvSpPr/>
+          <p:nvPr/>
+        </p:nvSpPr>
+        <p:spPr>
+          <a:xfrm>
+            <a:off x="9838944" y="1508760"/>
+            <a:ext cx="1234440" cy="841248"/>
+          </a:xfrm>
+          <a:prstGeom prst="rect">
+            <a:avLst/>
+          </a:prstGeom>
+          <a:noFill/>
+          <a:ln>
+            <a:noFill/>
+          </a:ln>
+        </p:spPr>
+        <p:txBody>
+          <a:bodyPr wrap="square" rtlCol="0"/>
+          <a:lstStyle/>
+          <a:p>
+            <a:pPr lvl="0">
+              <a:buNone/>
+            </a:pPr>
+            <a:r>
+              <a:rPr lang="en-US" sz="1400" b="1">
+                <a:solidFill>
+                  <a:srgbClr val="FFFFFF"/>
+                </a:solidFill>
+                <a:latin typeface="Aptos"/>
+              </a:rPr>
+              <a:t>UI</a:t>
+            </a:r>
+            <a:endParaRPr lang="en-US" sz="1400"/>
+          </a:p>
+          <a:p>
+            <a:pPr lvl="0">
+              <a:buNone/>
+            </a:pPr>
+            <a:r>
+              <a:rPr lang="en-US" sz="900">
+                <a:solidFill>
+                  <a:srgbClr val="EAF4F5"/>
+                </a:solidFill>
+                <a:latin typeface="Aptos"/>
+              </a:rPr>
+              <a:t>React/Vite</a:t>
+            </a:r>
+            <a:endParaRPr lang="en-US" sz="900"/>
           </a:p>
         </p:txBody>
       </p:sp>
@@ -1773,8 +4909,8 @@
         </p:nvSpPr>
         <p:spPr>
           <a:xfrm>
-            <a:off x="749808" y="1261872"/>
-            <a:ext cx="10698480" cy="4800600"/>
+            <a:off x="658368" y="1261872"/>
+            <a:ext cx="3886200" cy="4800600"/>
           </a:xfrm>
           <a:prstGeom prst="rect">
             <a:avLst/>
@@ -1792,7 +4928,7 @@
               <a:buChar char="•"/>
             </a:pPr>
             <a:r>
-              <a:rPr lang="en-US" sz="1700">
+              <a:rPr lang="en-US" sz="1500">
                 <a:solidFill>
                   <a:srgbClr val="26364D"/>
                 </a:solidFill>
@@ -1800,14 +4936,14 @@
               </a:rPr>
               <a:t>Replay held-out patient history</a:t>
             </a:r>
-            <a:endParaRPr lang="en-US" sz="1700"/>
+            <a:endParaRPr lang="en-US" sz="1500"/>
           </a:p>
           <a:p>
             <a:pPr lvl="0">
               <a:buChar char="•"/>
             </a:pPr>
             <a:r>
-              <a:rPr lang="en-US" sz="1700">
+              <a:rPr lang="en-US" sz="1500">
                 <a:solidFill>
                   <a:srgbClr val="26364D"/>
                 </a:solidFill>
@@ -1815,14 +4951,14 @@
               </a:rPr>
               <a:t>Three named forecast heads and intervals</a:t>
             </a:r>
-            <a:endParaRPr lang="en-US" sz="1700"/>
+            <a:endParaRPr lang="en-US" sz="1500"/>
           </a:p>
           <a:p>
             <a:pPr lvl="0">
               <a:buChar char="•"/>
             </a:pPr>
             <a:r>
-              <a:rPr lang="en-US" sz="1700">
+              <a:rPr lang="en-US" sz="1500">
                 <a:solidFill>
                   <a:srgbClr val="26364D"/>
                 </a:solidFill>
@@ -1830,14 +4966,14 @@
               </a:rPr>
               <a:t>Event state and risk when eligible</a:t>
             </a:r>
-            <a:endParaRPr lang="en-US" sz="1700"/>
+            <a:endParaRPr lang="en-US" sz="1500"/>
           </a:p>
           <a:p>
             <a:pPr lvl="0">
               <a:buChar char="•"/>
             </a:pPr>
             <a:r>
-              <a:rPr lang="en-US" sz="1700">
+              <a:rPr lang="en-US" sz="1500">
                 <a:solidFill>
                   <a:srgbClr val="26364D"/>
                 </a:solidFill>
@@ -1845,7 +4981,428 @@
               </a:rPr>
               <a:t>Dropout, provenance, limitations, and assumption-based scenario view</a:t>
             </a:r>
-            <a:endParaRPr lang="en-US" sz="1700"/>
+            <a:endParaRPr lang="en-US" sz="1500"/>
+          </a:p>
+        </p:txBody>
+      </p:sp>
+      <p:sp>
+        <p:nvSpPr>
+          <p:cNvPr id="20" name="card-20"/>
+          <p:cNvSpPr/>
+          <p:nvPr/>
+        </p:nvSpPr>
+        <p:spPr>
+          <a:xfrm>
+            <a:off x="4892040" y="1417320"/>
+            <a:ext cx="1417320" cy="1024128"/>
+          </a:xfrm>
+          <a:prstGeom prst="rect">
+            <a:avLst/>
+          </a:prstGeom>
+          <a:solidFill>
+            <a:srgbClr val="159B9A"/>
+          </a:solidFill>
+          <a:ln>
+            <a:noFill/>
+          </a:ln>
+        </p:spPr>
+      </p:sp>
+      <p:sp>
+        <p:nvSpPr>
+          <p:cNvPr id="21" name="card-text-20"/>
+          <p:cNvSpPr/>
+          <p:nvPr/>
+        </p:nvSpPr>
+        <p:spPr>
+          <a:xfrm>
+            <a:off x="4983480" y="1508760"/>
+            <a:ext cx="1234440" cy="841248"/>
+          </a:xfrm>
+          <a:prstGeom prst="rect">
+            <a:avLst/>
+          </a:prstGeom>
+          <a:noFill/>
+          <a:ln>
+            <a:noFill/>
+          </a:ln>
+        </p:spPr>
+        <p:txBody>
+          <a:bodyPr wrap="square" rtlCol="0"/>
+          <a:lstStyle/>
+          <a:p>
+            <a:pPr lvl="0">
+              <a:buNone/>
+            </a:pPr>
+            <a:r>
+              <a:rPr lang="en-US" sz="1400" b="1">
+                <a:solidFill>
+                  <a:srgbClr val="FFFFFF"/>
+                </a:solidFill>
+                <a:latin typeface="Aptos"/>
+              </a:rPr>
+              <a:t>SELECT</a:t>
+            </a:r>
+            <a:endParaRPr lang="en-US" sz="1400"/>
+          </a:p>
+          <a:p>
+            <a:pPr lvl="0">
+              <a:buNone/>
+            </a:pPr>
+            <a:r>
+              <a:rPr lang="en-US" sz="900">
+                <a:solidFill>
+                  <a:srgbClr val="EAF4F5"/>
+                </a:solidFill>
+                <a:latin typeface="Aptos"/>
+              </a:rPr>
+              <a:t>test patient</a:t>
+            </a:r>
+            <a:endParaRPr lang="en-US" sz="900"/>
+          </a:p>
+        </p:txBody>
+      </p:sp>
+      <p:sp>
+        <p:nvSpPr>
+          <p:cNvPr id="22" name="arrow-22"/>
+          <p:cNvSpPr/>
+          <p:nvPr/>
+        </p:nvSpPr>
+        <p:spPr>
+          <a:xfrm>
+            <a:off x="6318504" y="1700784"/>
+            <a:ext cx="260000" cy="430000"/>
+          </a:xfrm>
+          <a:prstGeom prst="rect">
+            <a:avLst/>
+          </a:prstGeom>
+          <a:noFill/>
+          <a:ln>
+            <a:noFill/>
+          </a:ln>
+        </p:spPr>
+        <p:txBody>
+          <a:bodyPr wrap="square" rtlCol="0"/>
+          <a:lstStyle/>
+          <a:p>
+            <a:pPr lvl="0">
+              <a:buNone/>
+            </a:pPr>
+            <a:r>
+              <a:rPr lang="en-US" sz="2200" b="1">
+                <a:solidFill>
+                  <a:srgbClr val="7667E8"/>
+                </a:solidFill>
+                <a:latin typeface="Aptos"/>
+              </a:rPr>
+              <a:t>→</a:t>
+            </a:r>
+            <a:endParaRPr lang="en-US" sz="2200"/>
+          </a:p>
+        </p:txBody>
+      </p:sp>
+      <p:sp>
+        <p:nvSpPr>
+          <p:cNvPr id="23" name="card-23"/>
+          <p:cNvSpPr/>
+          <p:nvPr/>
+        </p:nvSpPr>
+        <p:spPr>
+          <a:xfrm>
+            <a:off x="6510528" y="1417320"/>
+            <a:ext cx="1417320" cy="1024128"/>
+          </a:xfrm>
+          <a:prstGeom prst="rect">
+            <a:avLst/>
+          </a:prstGeom>
+          <a:solidFill>
+            <a:srgbClr val="7667E8"/>
+          </a:solidFill>
+          <a:ln>
+            <a:noFill/>
+          </a:ln>
+        </p:spPr>
+      </p:sp>
+      <p:sp>
+        <p:nvSpPr>
+          <p:cNvPr id="24" name="card-text-23"/>
+          <p:cNvSpPr/>
+          <p:nvPr/>
+        </p:nvSpPr>
+        <p:spPr>
+          <a:xfrm>
+            <a:off x="6601968" y="1508760"/>
+            <a:ext cx="1234440" cy="841248"/>
+          </a:xfrm>
+          <a:prstGeom prst="rect">
+            <a:avLst/>
+          </a:prstGeom>
+          <a:noFill/>
+          <a:ln>
+            <a:noFill/>
+          </a:ln>
+        </p:spPr>
+        <p:txBody>
+          <a:bodyPr wrap="square" rtlCol="0"/>
+          <a:lstStyle/>
+          <a:p>
+            <a:pPr lvl="0">
+              <a:buNone/>
+            </a:pPr>
+            <a:r>
+              <a:rPr lang="en-US" sz="1400" b="1">
+                <a:solidFill>
+                  <a:srgbClr val="FFFFFF"/>
+                </a:solidFill>
+                <a:latin typeface="Aptos"/>
+              </a:rPr>
+              <a:t>REPLAY</a:t>
+            </a:r>
+            <a:endParaRPr lang="en-US" sz="1400"/>
+          </a:p>
+          <a:p>
+            <a:pPr lvl="0">
+              <a:buNone/>
+            </a:pPr>
+            <a:r>
+              <a:rPr lang="en-US" sz="900">
+                <a:solidFill>
+                  <a:srgbClr val="EAF4F5"/>
+                </a:solidFill>
+                <a:latin typeface="Aptos"/>
+              </a:rPr>
+              <a:t>+5 min</a:t>
+            </a:r>
+            <a:endParaRPr lang="en-US" sz="900"/>
+          </a:p>
+        </p:txBody>
+      </p:sp>
+      <p:sp>
+        <p:nvSpPr>
+          <p:cNvPr id="25" name="arrow-25"/>
+          <p:cNvSpPr/>
+          <p:nvPr/>
+        </p:nvSpPr>
+        <p:spPr>
+          <a:xfrm>
+            <a:off x="7936992" y="1700784"/>
+            <a:ext cx="260000" cy="430000"/>
+          </a:xfrm>
+          <a:prstGeom prst="rect">
+            <a:avLst/>
+          </a:prstGeom>
+          <a:noFill/>
+          <a:ln>
+            <a:noFill/>
+          </a:ln>
+        </p:spPr>
+        <p:txBody>
+          <a:bodyPr wrap="square" rtlCol="0"/>
+          <a:lstStyle/>
+          <a:p>
+            <a:pPr lvl="0">
+              <a:buNone/>
+            </a:pPr>
+            <a:r>
+              <a:rPr lang="en-US" sz="2200" b="1">
+                <a:solidFill>
+                  <a:srgbClr val="7667E8"/>
+                </a:solidFill>
+                <a:latin typeface="Aptos"/>
+              </a:rPr>
+              <a:t>→</a:t>
+            </a:r>
+            <a:endParaRPr lang="en-US" sz="2200"/>
+          </a:p>
+        </p:txBody>
+      </p:sp>
+      <p:sp>
+        <p:nvSpPr>
+          <p:cNvPr id="26" name="card-26"/>
+          <p:cNvSpPr/>
+          <p:nvPr/>
+        </p:nvSpPr>
+        <p:spPr>
+          <a:xfrm>
+            <a:off x="8129016" y="1417320"/>
+            <a:ext cx="1417320" cy="1024128"/>
+          </a:xfrm>
+          <a:prstGeom prst="rect">
+            <a:avLst/>
+          </a:prstGeom>
+          <a:solidFill>
+            <a:srgbClr val="159B9A"/>
+          </a:solidFill>
+          <a:ln>
+            <a:noFill/>
+          </a:ln>
+        </p:spPr>
+      </p:sp>
+      <p:sp>
+        <p:nvSpPr>
+          <p:cNvPr id="27" name="card-text-26"/>
+          <p:cNvSpPr/>
+          <p:nvPr/>
+        </p:nvSpPr>
+        <p:spPr>
+          <a:xfrm>
+            <a:off x="8220456" y="1508760"/>
+            <a:ext cx="1234440" cy="841248"/>
+          </a:xfrm>
+          <a:prstGeom prst="rect">
+            <a:avLst/>
+          </a:prstGeom>
+          <a:noFill/>
+          <a:ln>
+            <a:noFill/>
+          </a:ln>
+        </p:spPr>
+        <p:txBody>
+          <a:bodyPr wrap="square" rtlCol="0"/>
+          <a:lstStyle/>
+          <a:p>
+            <a:pPr lvl="0">
+              <a:buNone/>
+            </a:pPr>
+            <a:r>
+              <a:rPr lang="en-US" sz="1400" b="1">
+                <a:solidFill>
+                  <a:srgbClr val="FFFFFF"/>
+                </a:solidFill>
+                <a:latin typeface="Aptos"/>
+              </a:rPr>
+              <a:t>FORECAST</a:t>
+            </a:r>
+            <a:endParaRPr lang="en-US" sz="1400"/>
+          </a:p>
+          <a:p>
+            <a:pPr lvl="0">
+              <a:buNone/>
+            </a:pPr>
+            <a:r>
+              <a:rPr lang="en-US" sz="900">
+                <a:solidFill>
+                  <a:srgbClr val="EAF4F5"/>
+                </a:solidFill>
+                <a:latin typeface="Aptos"/>
+              </a:rPr>
+              <a:t>heads + bands</a:t>
+            </a:r>
+            <a:endParaRPr lang="en-US" sz="900"/>
+          </a:p>
+        </p:txBody>
+      </p:sp>
+      <p:sp>
+        <p:nvSpPr>
+          <p:cNvPr id="28" name="arrow-28"/>
+          <p:cNvSpPr/>
+          <p:nvPr/>
+        </p:nvSpPr>
+        <p:spPr>
+          <a:xfrm>
+            <a:off x="9555480" y="1700784"/>
+            <a:ext cx="260000" cy="430000"/>
+          </a:xfrm>
+          <a:prstGeom prst="rect">
+            <a:avLst/>
+          </a:prstGeom>
+          <a:noFill/>
+          <a:ln>
+            <a:noFill/>
+          </a:ln>
+        </p:spPr>
+        <p:txBody>
+          <a:bodyPr wrap="square" rtlCol="0"/>
+          <a:lstStyle/>
+          <a:p>
+            <a:pPr lvl="0">
+              <a:buNone/>
+            </a:pPr>
+            <a:r>
+              <a:rPr lang="en-US" sz="2200" b="1">
+                <a:solidFill>
+                  <a:srgbClr val="7667E8"/>
+                </a:solidFill>
+                <a:latin typeface="Aptos"/>
+              </a:rPr>
+              <a:t>→</a:t>
+            </a:r>
+            <a:endParaRPr lang="en-US" sz="2200"/>
+          </a:p>
+        </p:txBody>
+      </p:sp>
+      <p:sp>
+        <p:nvSpPr>
+          <p:cNvPr id="29" name="card-29"/>
+          <p:cNvSpPr/>
+          <p:nvPr/>
+        </p:nvSpPr>
+        <p:spPr>
+          <a:xfrm>
+            <a:off x="9747504" y="1417320"/>
+            <a:ext cx="1417320" cy="1024128"/>
+          </a:xfrm>
+          <a:prstGeom prst="rect">
+            <a:avLst/>
+          </a:prstGeom>
+          <a:solidFill>
+            <a:srgbClr val="7667E8"/>
+          </a:solidFill>
+          <a:ln>
+            <a:noFill/>
+          </a:ln>
+        </p:spPr>
+      </p:sp>
+      <p:sp>
+        <p:nvSpPr>
+          <p:cNvPr id="30" name="card-text-29"/>
+          <p:cNvSpPr/>
+          <p:nvPr/>
+        </p:nvSpPr>
+        <p:spPr>
+          <a:xfrm>
+            <a:off x="9838944" y="1508760"/>
+            <a:ext cx="1234440" cy="841248"/>
+          </a:xfrm>
+          <a:prstGeom prst="rect">
+            <a:avLst/>
+          </a:prstGeom>
+          <a:noFill/>
+          <a:ln>
+            <a:noFill/>
+          </a:ln>
+        </p:spPr>
+        <p:txBody>
+          <a:bodyPr wrap="square" rtlCol="0"/>
+          <a:lstStyle/>
+          <a:p>
+            <a:pPr lvl="0">
+              <a:buNone/>
+            </a:pPr>
+            <a:r>
+              <a:rPr lang="en-US" sz="1400" b="1">
+                <a:solidFill>
+                  <a:srgbClr val="FFFFFF"/>
+                </a:solidFill>
+                <a:latin typeface="Aptos"/>
+              </a:rPr>
+              <a:t>EVIDENCE</a:t>
+            </a:r>
+            <a:endParaRPr lang="en-US" sz="1400"/>
+          </a:p>
+          <a:p>
+            <a:pPr lvl="0">
+              <a:buNone/>
+            </a:pPr>
+            <a:r>
+              <a:rPr lang="en-US" sz="900">
+                <a:solidFill>
+                  <a:srgbClr val="EAF4F5"/>
+                </a:solidFill>
+                <a:latin typeface="Aptos"/>
+              </a:rPr>
+              <a:t>limitations</a:t>
+            </a:r>
+            <a:endParaRPr lang="en-US" sz="900"/>
           </a:p>
         </p:txBody>
       </p:sp>
@@ -2004,7 +5561,7 @@
         </p:nvSpPr>
         <p:spPr>
           <a:xfrm>
-            <a:off x="749808" y="1261872"/>
+            <a:off x="658368" y="1261872"/>
             <a:ext cx="10698480" cy="4800600"/>
           </a:xfrm>
           <a:prstGeom prst="rect">

</xml_diff>